<commit_message>
Refine Gartner note, Iansiti and Lakhani definition and rare-box wording
Co-Authored-By: Claude Sonnet 5.5 <noreply@anthropic.com>
Claude-Session: https://claude.ai/code/session_01PRvXFuBN7ZYwDJRpkf6We3
</commit_message>
<xml_diff>
--- a/Ledger_of_Record_updated.pptx
+++ b/Ledger_of_Record_updated.pptx
@@ -1025,7 +1025,7 @@
                 <a:latin typeface="Times New Roman"/>
                 <a:cs typeface="Times New Roman"/>
               </a:rPr>
-              <a:t>Definition: Iansiti and Lakhani (2017) describe blockchain as an open, distributed ledger that can record transactions between two parties efficiently and in a verifiable and permanent way, and that can be programmed to trigger transactions automatically. That last clause is the smart-contract idea on the right of this slide.</a:t>
+              <a:t>Definition: Iansiti and Lakhani (2017) describe blockchain as an open, distributed ledger that can record transactions between two parties efficiently and in a verifiable and permanent way, and that can be programmed to trigger transactions automatically. That last clause is the smart-contract idea on the right of this slide. They also call it a foundational technology, like the internet, that will take years to transform markets rather than a quick disruption.</a:t>
             </a:r>
           </a:p>
         </p:txBody>
@@ -1256,7 +1256,7 @@
                 <a:latin typeface="Times New Roman"/>
                 <a:cs typeface="Times New Roman"/>
               </a:rPr>
-              <a:t>Hype Cycle: Gartner placed most blockchain technologies past the peak and sliding into the Trough of Disillusionment in its 2024 Hype Cycle for Web3 and Blockchain, with smart contracts entering the trough. For Apple TV+ that argues for a staged pilot that proves value, not a big-bang launch. Gartner has said it may not publish another blockchain hype cycle, so 2024 is the latest position I could find.</a:t>
+              <a:t>Hype Cycle: Gartner placed most blockchain technologies past the peak and sliding into the Trough of Disillusionment in its 2024 Hype Cycle for Web3 and Blockchain, with smart contracts entering the trough. For Apple TV+ that argues for a staged pilot that proves value, not a big-bang launch. Gartner has said it may not publish another blockchain hype cycle; its 2025 Hype Cycle for Emerging Technologies instead covers blockchain-based tokenisation and smart contracts under programmable money, within the Autonomous Business theme.</a:t>
             </a:r>
           </a:p>
           <a:p>
@@ -17208,7 +17208,7 @@
                 </a:solidFill>
                 <a:latin typeface="Times New Roman"/>
               </a:rPr>
-              <a:t>an open, distributed ledger that records transactions between parties in a verifiable and permanent way, and can be programmed to trigger transactions automatically (Iansiti and Lakhani, 2017).</a:t>
+              <a:t>a foundational technology: an open, distributed ledger that records transactions between parties in a verifiable and permanent way, and can be programmed to trigger transactions automatically (Iansiti and Lakhani, 2017).</a:t>
             </a:r>
           </a:p>
         </p:txBody>
@@ -20431,13 +20431,13 @@
               <a:t>Blockchain is entering the Trough of Disillusionment (Gartner, 2024). </a:t>
             </a:r>
             <a:r>
-              <a:rPr lang="en-GB" sz="1300" b="0" i="0" dirty="0">
+              <a:rPr lang="en-GB" sz="1200" b="0" i="0" dirty="0">
                 <a:solidFill>
                   <a:srgbClr val="2A2218"/>
                 </a:solidFill>
                 <a:latin typeface="Times New Roman"/>
               </a:rPr>
-              <a:t>Hype has cooled, so Apple TV+ should prove value in one territory before it scales.</a:t>
+              <a:t>Hype has cooled, so prove value in one territory before scaling. Gartner’s 2025 emerging-tech cycle now tracks it as programmable money.</a:t>
             </a:r>
           </a:p>
         </p:txBody>
@@ -25518,7 +25518,7 @@
                 </a:solidFill>
                 <a:latin typeface="Times New Roman"/>
               </a:rPr>
-              <a:t>no major video streamer found using one, only music pilots, so Apple TV+ would be early.</a:t>
+              <a:t>no major video streamer found using one as core infrastructure, so Apple TV+ would be early.</a:t>
             </a:r>
           </a:p>
         </p:txBody>

</xml_diff>

<commit_message>
Add critical insight paragraphs to speaker notes
Co-Authored-By: Claude Sonnet 5.5 <noreply@anthropic.com>
Claude-Session: https://claude.ai/code/session_01PRvXFuBN7ZYwDJRpkf6We3
</commit_message>
<xml_diff>
--- a/Ledger_of_Record_updated.pptx
+++ b/Ledger_of_Record_updated.pptx
@@ -649,6 +649,14 @@
               <a:t>Smart-contract error is the most serious risk, linked to the encoding gap on slide five. A wrong term in code keeps paying the wrong party until someone notices. The control is mandatory legal and technical sign-off before go-live, plus a manual override and dispute freeze.</a:t>
             </a:r>
           </a:p>
+          <a:p>
+            <a:r>
+              <a:rPr>
+                <a:latin typeface="Times New Roman"/>
+              </a:rPr>
+              <a:t>Critical insight: the three risks interact. A coding error, the most serious, is harder to correct on an immutable ledger, and correcting it may touch personal data, which brings in GDPR. So the controls work as a set: off-chain data, sign-off and a freeze each cover another’s gap. Cross-border regulation is the risk Apple TV+ cannot fully control, which is why rollout order matters.</a:t>
+            </a:r>
+          </a:p>
         </p:txBody>
       </p:sp>
       <p:sp>
@@ -754,6 +762,14 @@
               <a:t>Against the three guiding questions: on feasibility, the mechanism cuts real agency and monitoring costs but adds an encoding-risk point. On people and processes, legal and rights concerns are legitimate and need governance, not reassurance. On sustained advantage, the edge lies in accumulated trust and payment history, which Apple TV+ has to keep building.</a:t>
             </a:r>
           </a:p>
+          <a:p>
+            <a:r>
+              <a:rPr>
+                <a:latin typeface="Times New Roman"/>
+              </a:rPr>
+              <a:t>Critical insight: the conclusion is conditional, not enthusiastic, which is the honest reading of the evidence. The theories explain why the ledger can lower monitoring and agency costs, while the legal and organisational evidence shows what must be in place first. For Apple TV+ the practical answer is a staged, governed pilot judged against a measured baseline, not a company-wide commitment.</a:t>
+            </a:r>
+          </a:p>
         </p:txBody>
       </p:sp>
       <p:sp>
@@ -851,6 +867,14 @@
               <a:t>First, transaction cost economics supports a standing governance function that regularly reviews whether the system is still reducing contracting costs as Apple TV+ adds new territories and rights types. Second, agency theory supports mandatory dual sign-off, because it addresses the new agency risk created when contract terms are translated into code. Third, institutional isomorphism suggests the first-mover advantage is temporary by design, so Apple TV+ should invest in relationships, accumulated trust and verified payment history, not rely on the technology once competitors move.</a:t>
             </a:r>
           </a:p>
+          <a:p>
+            <a:r>
+              <a:rPr>
+                <a:latin typeface="Times New Roman"/>
+              </a:rPr>
+              <a:t>Critical insight: each recommendation turns a theory into an action with an owner. Governance review answers the transaction cost risk, dual sign-off answers the agency risk, and relationship investment answers the isomorphism risk. They also cost little compared with the technology, so they are where management effort changes the outcome.</a:t>
+            </a:r>
+          </a:p>
         </p:txBody>
       </p:sp>
       <p:sp>
@@ -948,6 +972,14 @@
               <a:t>Barrier: legal and rights teams fear answering for a wrongly coded payment, reduced by dual sign-off, a manual override and a dispute freeze. Digital confidence: Legal, Rights Ops and Finance are trained before the pilot on how the record works, reading a smart-contract term, and when to freeze a payment.</a:t>
             </a:r>
           </a:p>
+          <a:p>
+            <a:r>
+              <a:rPr>
+                <a:latin typeface="Times New Roman"/>
+              </a:rPr>
+              <a:t>Critical insight: TAM predicts adoption from usefulness and ease of use, but these teams carry personal accountability, so trust in the output matters as much as either. That is why the barrier box focuses on the ability to stop a payment. Kotter’s model also assumes a sponsor who can drive change; the named owner supplies that, and without one the pilot’s wins would not spread. A limit of both models: they describe attitudes, not whether the law will accept the ledger.</a:t>
+            </a:r>
+          </a:p>
         </p:txBody>
       </p:sp>
       <p:sp>
@@ -1043,6 +1075,14 @@
                 <a:latin typeface="Times New Roman"/>
               </a:rPr>
               <a:t>One objection: this is a music problem, not a film and TV one. It is not, because Apple TV+ clears music sync rights and talent agreements across the same territories, so the same many-parties, many-territories structure applies to both. That exposure is growing with the licensing expansion. The mechanism already exists elsewhere; what is open is how it is governed here.</a:t>
+            </a:r>
+          </a:p>
+          <a:p>
+            <a:r>
+              <a:rPr>
+                <a:latin typeface="Times New Roman"/>
+              </a:rPr>
+              <a:t>Critical insight: the $424 million figure comes from music mechanicals, so it shows the shape of the problem, not Apple TV+’s own loss. The transferable point is structural: manual matching fails as parties multiply. Apple TV+ should therefore measure its own dispute rate and reconciliation cost before the pilot, so any benefit claimed later can be tested against a baseline.</a:t>
             </a:r>
           </a:p>
         </p:txBody>
@@ -1150,6 +1190,14 @@
               <a:t>Definition: Iansiti and Lakhani (2017) describe blockchain as an open, distributed ledger that records transactions between two parties in a verifiable and permanent way and can be programmed to trigger transactions automatically. They call it a foundational technology, like the internet, that takes years to transform markets rather than a quick disruption.</a:t>
             </a:r>
           </a:p>
+          <a:p>
+            <a:r>
+              <a:rPr>
+                <a:latin typeface="Times New Roman"/>
+              </a:rPr>
+              <a:t>Critical insight: Iansiti and Lakhani’s point that blockchain is foundational, not disruptive, fits this case. Apple TV+ is not replacing a business model; it is changing how a record is shared. But a shared ledger only helps if counterparties actually join it, so its value depends on adoption by talent and rights holders, which is a relationship task as much as a technical one.</a:t>
+            </a:r>
+          </a:p>
         </p:txBody>
       </p:sp>
       <p:sp>
@@ -1255,6 +1303,14 @@
               <a:t>The limit: Williamson can show the ledger may govern more efficiently, but not that a court in every territory would treat an automatically executed payment as legally binding. That legal gap is central to the next stage of the argument.</a:t>
             </a:r>
           </a:p>
+          <a:p>
+            <a:r>
+              <a:rPr>
+                <a:latin typeface="Times New Roman"/>
+              </a:rPr>
+              <a:t>Critical insight: transaction cost economics also warns that new governance has its own costs. Writing terms as code, auditing it and paying for the platform are transaction costs too, so the ledger pays off only where the monitoring cost saved is greater. That favours territories with frequent, standard payments and argues against encoding rare, heavily negotiated deals first.</a:t>
+            </a:r>
+          </a:p>
         </p:txBody>
       </p:sp>
       <p:sp>
@@ -1376,6 +1432,14 @@
               <a:t>Hype Cycle: Gartner’s 2024 Hype Cycle for Web3 and Blockchain placed most blockchain technologies past the peak and sliding into the Trough of Disillusionment, with smart contracts entering it. That argues for a staged pilot, not a big-bang launch. Gartner may not publish another blockchain cycle; its 2025 emerging-technologies cycle covers tokenisation and smart contracts under programmable money, within Autonomous Business.</a:t>
             </a:r>
           </a:p>
+          <a:p>
+            <a:r>
+              <a:rPr>
+                <a:latin typeface="Times New Roman"/>
+              </a:rPr>
+              <a:t>Critical insight: agency theory is persuasive on discretion but incomplete. Removing discretion helps routine payments, yet royalty disputes often arise from ambiguity in the terms, which code cannot resolve and may harden. Gartner’s trough position supports caution for the same reason: the technology works, but the legal and business conditions around it are still maturing. The case therefore rests on narrow, well-defined payment rules, not on blockchain in general.</a:t>
+            </a:r>
+          </a:p>
         </p:txBody>
       </p:sp>
       <p:sp>
@@ -1489,6 +1553,14 @@
               <a:t>Value chain (Porter, 1985): technology development changes because royalty rules become reviewed smart-contract code that Legal and engineers sign off together. Inbound logistics, receiving content and talent rights, changes because rights windows and payment terms are read from one shared record, not re-confirmed by hand in every territory.</a:t>
             </a:r>
           </a:p>
+          <a:p>
+            <a:r>
+              <a:rPr>
+                <a:latin typeface="Times New Roman"/>
+              </a:rPr>
+              <a:t>Critical insight: Porter’s value chain shows the benefit does not sit in one function; it spreads across activities, which is why a single named owner matters. Without one, each function optimises its own step and the ledger becomes a fourth record. The theory turns a technology choice into an organisational design choice.</a:t>
+            </a:r>
+          </a:p>
         </p:txBody>
       </p:sp>
       <p:sp>
@@ -1602,6 +1674,14 @@
               <a:t>My response is sequencing, not reassurance: a phased rollout starting in territories with clearer digital-contract rules, keeping personal data off the ledger, a pilot in one territory with Legal in the design team, and a standing legal review as territories are added. The written contract stays the master and the ledger executes it.</a:t>
             </a:r>
           </a:p>
+          <a:p>
+            <a:r>
+              <a:rPr>
+                <a:latin typeface="Times New Roman"/>
+              </a:rPr>
+              <a:t>Critical insight: the legal teams’ concerns show why this is not a technology project. Werbach and Cornell’s point means the ledger can only execute a contract that law already recognises. So Legal acts as a design authority, not a late reviewer, and its approval is the real gate for each new territory.</a:t>
+            </a:r>
+          </a:p>
         </p:txBody>
       </p:sp>
       <p:sp>
@@ -1716,6 +1796,14 @@
               <a:t>One assumption needs testing: the ledger is a differentiator only while competitors lack it. Whether the advantage lasts is the next slide.</a:t>
             </a:r>
           </a:p>
+          <a:p>
+            <a:r>
+              <a:rPr>
+                <a:latin typeface="Times New Roman"/>
+              </a:rPr>
+              <a:t>Critical insight: the trust argument is a resource-based claim, not a technology claim. Accurate payments build a track record that rivals cannot buy. But the logic cuts both ways: one visible error damages trust faster than many correct payments build it, so the sign-off controls on slide eleven protect the strategic benefit as well as the money.</a:t>
+            </a:r>
+          </a:p>
         </p:txBody>
       </p:sp>
       <p:sp>
@@ -1828,6 +1916,14 @@
                 <a:latin typeface="Times New Roman"/>
               </a:rPr>
               <a:t>VRIO (Barney, 1991). Valuable: yes, fewer disputes. Rare: yes for now; my searches found no major video streamer running a rights ledger, only music-side efforts such as Spotify’s 2017 Mediachain purchase and vendor platforms such as Tech Mahindra’s bCRMS, but absence of evidence is not proof. Hard to imitate: the code is copyable, the payment history is not. Organised: a named owner and team are proposed on slide six, but dual sign-off and standing legal review are still needed. Verdict: the advantage is temporary until the organisation and trust are built.</a:t>
+            </a:r>
+          </a:p>
+          <a:p>
+            <a:r>
+              <a:rPr>
+                <a:latin typeface="Times New Roman"/>
+              </a:rPr>
+              <a:t>Critical insight: isomorphism and VRIO point the same way. Because the technology is easy to copy, only the organisation and the relationships can be a lasting source of advantage, which is why Organised is the weakest test today. Barney’s framework also assumes a stable resource; here the resource, a record of verified payments, grows with use, so the advantage depends on starting early and running without visible errors.</a:t>
             </a:r>
           </a:p>
         </p:txBody>

</xml_diff>

<commit_message>
Blend critical insights into the theory paragraphs of the speaker notes
Co-Authored-By: Claude Sonnet 5.5 <noreply@anthropic.com>
Claude-Session: https://claude.ai/code/session_01PRvXFuBN7ZYwDJRpkf6We3
</commit_message>
<xml_diff>
--- a/Ledger_of_Record_updated.pptx
+++ b/Ledger_of_Record_updated.pptx
@@ -622,7 +622,7 @@
               <a:rPr>
                 <a:latin typeface="Times New Roman"/>
               </a:rPr>
-              <a:t>Three separate risks, each with its own cause, owner and mitigation.</a:t>
+              <a:t>Three separate risks, each with its own cause, owner and mitigation, though they interact.</a:t>
             </a:r>
           </a:p>
           <a:p>
@@ -638,7 +638,7 @@
               <a:rPr>
                 <a:latin typeface="Times New Roman"/>
               </a:rPr>
-              <a:t>Cross-border regulation: there is no settled international standard for enforcing smart-contract royalties. The mitigation is the phased rollout by territory from slide seven, starting where digital-contract law is clearer.</a:t>
+              <a:t>Cross-border regulation: there is no settled international standard for enforcing smart-contract royalties. The mitigation is the phased rollout by territory from slide seven, starting where digital-contract law is clearer. This is the risk Apple TV+ cannot fully control, which is why rollout order matters.</a:t>
             </a:r>
           </a:p>
           <a:p>
@@ -646,15 +646,7 @@
               <a:rPr>
                 <a:latin typeface="Times New Roman"/>
               </a:rPr>
-              <a:t>Smart-contract error is the most serious risk, linked to the encoding gap on slide five. A wrong term in code keeps paying the wrong party until someone notices. The control is mandatory legal and technical sign-off before go-live, plus a manual override and dispute freeze.</a:t>
-            </a:r>
-          </a:p>
-          <a:p>
-            <a:r>
-              <a:rPr>
-                <a:latin typeface="Times New Roman"/>
-              </a:rPr>
-              <a:t>Critical insight: the three risks interact. A coding error, the most serious, is harder to correct on an immutable ledger, and correcting it may touch personal data, which brings in GDPR. So the controls work as a set: off-chain data, sign-off and a freeze each cover another’s gap. Cross-border regulation is the risk Apple TV+ cannot fully control, which is why rollout order matters.</a:t>
+              <a:t>Smart-contract error is the most serious risk, linked to the encoding gap on slide five. A wrong term in code keeps paying the wrong party until someone notices. The control is mandatory legal and technical sign-off before go-live, plus a manual override and dispute freeze. The risks interact: an error is harder to correct on an immutable ledger, and correcting it may touch personal data, so the controls work as a set, with off-chain data, sign-off and a freeze each covering another’s gap.</a:t>
             </a:r>
           </a:p>
         </p:txBody>
@@ -759,15 +751,7 @@
               <a:rPr>
                 <a:latin typeface="Times New Roman"/>
               </a:rPr>
-              <a:t>Against the three guiding questions: on feasibility, the mechanism cuts real agency and monitoring costs but adds an encoding-risk point. On people and processes, legal and rights concerns are legitimate and need governance, not reassurance. On sustained advantage, the edge lies in accumulated trust and payment history, which Apple TV+ has to keep building.</a:t>
-            </a:r>
-          </a:p>
-          <a:p>
-            <a:r>
-              <a:rPr>
-                <a:latin typeface="Times New Roman"/>
-              </a:rPr>
-              <a:t>Critical insight: the conclusion is conditional, not enthusiastic, which is the honest reading of the evidence. The theories explain why the ledger can lower monitoring and agency costs, while the legal and organisational evidence shows what must be in place first. For Apple TV+ the practical answer is a staged, governed pilot judged against a measured baseline, not a company-wide commitment.</a:t>
+              <a:t>Against the three guiding questions: on feasibility, the mechanism cuts real agency and monitoring costs but adds an encoding-risk point. On people and processes, legal and rights concerns are legitimate and need governance, not reassurance. On sustained advantage, the edge lies in accumulated trust and payment history, which Apple TV+ has to keep building. The conclusion is therefore conditional, not enthusiastic: the practical answer is a staged, governed pilot judged against a measured baseline, not a company-wide commitment.</a:t>
             </a:r>
           </a:p>
         </p:txBody>
@@ -856,7 +840,7 @@
               <a:rPr>
                 <a:latin typeface="Times New Roman"/>
               </a:rPr>
-              <a:t>Three practical recommendations, each grounded in a theory used earlier.</a:t>
+              <a:t>Three practical recommendations, each turning a theory used earlier into an action with an owner.</a:t>
             </a:r>
           </a:p>
           <a:p>
@@ -864,15 +848,7 @@
               <a:rPr>
                 <a:latin typeface="Times New Roman"/>
               </a:rPr>
-              <a:t>First, transaction cost economics supports a standing governance function that regularly reviews whether the system is still reducing contracting costs as Apple TV+ adds new territories and rights types. Second, agency theory supports mandatory dual sign-off, because it addresses the new agency risk created when contract terms are translated into code. Third, institutional isomorphism suggests the first-mover advantage is temporary by design, so Apple TV+ should invest in relationships, accumulated trust and verified payment history, not rely on the technology once competitors move.</a:t>
-            </a:r>
-          </a:p>
-          <a:p>
-            <a:r>
-              <a:rPr>
-                <a:latin typeface="Times New Roman"/>
-              </a:rPr>
-              <a:t>Critical insight: each recommendation turns a theory into an action with an owner. Governance review answers the transaction cost risk, dual sign-off answers the agency risk, and relationship investment answers the isomorphism risk. They also cost little compared with the technology, so they are where management effort changes the outcome.</a:t>
+              <a:t>First, transaction cost economics supports a standing governance function that regularly reviews whether the system is still reducing contracting costs as Apple TV+ adds new territories and rights types. Second, agency theory supports mandatory dual sign-off, because it addresses the new agency risk created when contract terms are translated into code. Third, institutional isomorphism suggests the first-mover advantage is temporary by design, so Apple TV+ should invest in relationships, accumulated trust and verified payment history, not rely on the technology once competitors move. All three cost little compared with the technology, so they are where management effort changes the outcome.</a:t>
             </a:r>
           </a:p>
         </p:txBody>
@@ -953,7 +929,7 @@
               <a:rPr>
                 <a:latin typeface="Times New Roman"/>
               </a:rPr>
-              <a:t>TAM (Davis, 1989): usefulness comes from answering the concerns on slide seven, a verifiable record for regulators, the written contract kept as master, and no extra version of the truth. Ease of use is hurt by unfamiliar tools, coding and integration, and helped by plugging into current systems, no coding by users and a simple read-only view.</a:t>
+              <a:t>TAM (Davis, 1989): usefulness comes from answering the concerns on slide seven, a verifiable record for regulators, the written contract kept as master, and no extra version of the truth. Ease of use is hurt by unfamiliar tools, coding and integration, and helped by plugging into current systems, no coding by users and a simple read-only view. TAM predicts adoption from usefulness and ease of use, but these teams carry personal accountability, so trust in the output matters as much as either, which is why the barrier box focuses on the ability to stop a payment.</a:t>
             </a:r>
           </a:p>
           <a:p>
@@ -961,7 +937,7 @@
               <a:rPr>
                 <a:latin typeface="Times New Roman"/>
               </a:rPr>
-              <a:t>Kotter (1996) has eight steps; I use three in order. Step 2, guiding coalition: Legal, Rights Ops and Finance in the design team under one named owner. Step 6, short-term wins: pilot in one territory and share the results. Step 8, anchor in the culture: make the quarterly review permanent.</a:t>
+              <a:t>Kotter (1996) has eight steps; I use three in order. Step 2, guiding coalition: Legal, Rights Ops and Finance in the design team under one named owner. Step 6, short-term wins: pilot in one territory and share the results. Step 8, anchor in the culture: make the quarterly review permanent. Kotter’s model assumes a sponsor who can drive change; the named owner supplies that, and without one the pilot’s wins would not spread. A limit of both models is that they describe attitudes, not whether the law will accept the ledger.</a:t>
             </a:r>
           </a:p>
           <a:p>
@@ -970,14 +946,6 @@
                 <a:latin typeface="Times New Roman"/>
               </a:rPr>
               <a:t>Barrier: legal and rights teams fear answering for a wrongly coded payment, reduced by dual sign-off, a manual override and a dispute freeze. Digital confidence: Legal, Rights Ops and Finance are trained before the pilot on how the record works, reading a smart-contract term, and when to freeze a payment.</a:t>
-            </a:r>
-          </a:p>
-          <a:p>
-            <a:r>
-              <a:rPr>
-                <a:latin typeface="Times New Roman"/>
-              </a:rPr>
-              <a:t>Critical insight: TAM predicts adoption from usefulness and ease of use, but these teams carry personal accountability, so trust in the output matters as much as either. That is why the barrier box focuses on the ability to stop a payment. Kotter’s model also assumes a sponsor who can drive change; the named owner supplies that, and without one the pilot’s wins would not spread. A limit of both models: they describe attitudes, not whether the law will accept the ledger.</a:t>
             </a:r>
           </a:p>
         </p:txBody>
@@ -1058,7 +1026,7 @@
               <a:rPr>
                 <a:latin typeface="Times New Roman"/>
               </a:rPr>
-              <a:t>The music industry shows what happens when this goes wrong, so I use it as a supporting example. The Mechanical Licensing Collective holds over $424 million in historical unmatched streaming royalties, collected but never matched to the people owed it (Billboard, 2023). Sharp (2023) argues this is the visible symptom of manual matching across too many rights holders and territories.</a:t>
+              <a:t>The music industry shows what happens when this goes wrong, so I use it as a supporting example. The Mechanical Licensing Collective holds over $424 million in historical unmatched streaming royalties, collected but never matched to the people owed it (Billboard, 2023). Sharp (2023) argues this is the visible symptom of manual matching across too many rights holders and territories. The figure comes from music mechanicals, so it shows the shape of the problem, not Apple TV+’s own loss; the transferable point is structural, that manual matching fails as parties multiply.</a:t>
             </a:r>
           </a:p>
           <a:p>
@@ -1074,15 +1042,7 @@
               <a:rPr>
                 <a:latin typeface="Times New Roman"/>
               </a:rPr>
-              <a:t>One objection: this is a music problem, not a film and TV one. It is not, because Apple TV+ clears music sync rights and talent agreements across the same territories, so the same many-parties, many-territories structure applies to both. That exposure is growing with the licensing expansion. The mechanism already exists elsewhere; what is open is how it is governed here.</a:t>
-            </a:r>
-          </a:p>
-          <a:p>
-            <a:r>
-              <a:rPr>
-                <a:latin typeface="Times New Roman"/>
-              </a:rPr>
-              <a:t>Critical insight: the $424 million figure comes from music mechanicals, so it shows the shape of the problem, not Apple TV+’s own loss. The transferable point is structural: manual matching fails as parties multiply. Apple TV+ should therefore measure its own dispute rate and reconciliation cost before the pilot, so any benefit claimed later can be tested against a baseline.</a:t>
+              <a:t>One objection: this is a music problem, not a film and TV one. It is not, because Apple TV+ clears music sync rights and talent agreements across the same territories, so the same many-parties, many-territories structure applies to both, and the exposure grows with the licensing expansion. The mechanism already exists elsewhere; what is open is how it is governed here. Apple TV+ should therefore measure its own dispute rate and reconciliation cost before any pilot, so a benefit claimed later can be tested against a baseline.</a:t>
             </a:r>
           </a:p>
         </p:txBody>
@@ -1179,7 +1139,7 @@
               <a:rPr>
                 <a:latin typeface="Times New Roman"/>
               </a:rPr>
-              <a:t>This is not just a rights database with more permissions. A conventional database makes every participant rely on whoever controls it, often one of the counterparties. A shared ledger lets each authorised party verify the record independently. Zhao and O’Mahony (2018) showed this for music rights with a working prototype, BMCProtector, and García et al. (2023) show research has moved from feasibility to the legal and business questions this briefing addresses.</a:t>
+              <a:t>This is not just a rights database with more permissions. A conventional database makes every participant rely on whoever controls it, often one of the counterparties. A shared ledger lets each authorised party verify the record independently. Zhao and O’Mahony (2018) showed this for music rights with a working prototype, BMCProtector, and García et al. (2023) show research has moved from feasibility to the legal and business questions this briefing addresses. But a shared ledger only helps if counterparties actually join it, so its value depends on adoption by talent and rights holders, a relationship task as much as a technical one.</a:t>
             </a:r>
           </a:p>
           <a:p>
@@ -1187,15 +1147,7 @@
               <a:rPr>
                 <a:latin typeface="Times New Roman"/>
               </a:rPr>
-              <a:t>Definition: Iansiti and Lakhani (2017) describe blockchain as an open, distributed ledger that records transactions between two parties in a verifiable and permanent way and can be programmed to trigger transactions automatically. They call it a foundational technology, like the internet, that takes years to transform markets rather than a quick disruption.</a:t>
-            </a:r>
-          </a:p>
-          <a:p>
-            <a:r>
-              <a:rPr>
-                <a:latin typeface="Times New Roman"/>
-              </a:rPr>
-              <a:t>Critical insight: Iansiti and Lakhani’s point that blockchain is foundational, not disruptive, fits this case. Apple TV+ is not replacing a business model; it is changing how a record is shared. But a shared ledger only helps if counterparties actually join it, so its value depends on adoption by talent and rights holders, which is a relationship task as much as a technical one.</a:t>
+              <a:t>Definition: Iansiti and Lakhani (2017) describe blockchain as an open, distributed ledger that records transactions between two parties in a verifiable and permanent way and can be programmed to trigger transactions automatically. They call it a foundational technology, like the internet, that takes years to transform markets rather than a quick disruption. That fits this case: Apple TV+ is not replacing a business model, it is changing how a record is shared.</a:t>
             </a:r>
           </a:p>
         </p:txBody>
@@ -1292,7 +1244,7 @@
               <a:rPr>
                 <a:latin typeface="Times New Roman"/>
               </a:rPr>
-              <a:t>Williamson’s (1979) transaction cost economics explains why this matters. Firms choose governance structures to minimise the cost of contracting under uncertainty, and a ledger can be read as a governance mechanism that cuts the cost of monitoring and enforcing multi-party agreements. Confirmation and monitoring are transaction costs, so automating the trigger changes how the agreement is governed, not just how fast it runs.</a:t>
+              <a:t>Williamson’s (1979) transaction cost economics explains why this matters. Firms choose governance structures to minimise the cost of contracting under uncertainty, and a ledger can be read as a governance mechanism that cuts the cost of monitoring and enforcing multi-party agreements. Confirmation and monitoring are transaction costs, so automating the trigger changes how the agreement is governed, not just how fast it runs. New governance has its own costs, though: writing terms as code, auditing it and paying for the platform are transaction costs too. So the ledger pays off only where the monitoring cost saved is greater, which favours territories with frequent, standard payments and argues against encoding rare, heavily negotiated deals first.</a:t>
             </a:r>
           </a:p>
           <a:p>
@@ -1301,14 +1253,6 @@
                 <a:latin typeface="Times New Roman"/>
               </a:rPr>
               <a:t>The limit: Williamson can show the ledger may govern more efficiently, but not that a court in every territory would treat an automatically executed payment as legally binding. That legal gap is central to the next stage of the argument.</a:t>
-            </a:r>
-          </a:p>
-          <a:p>
-            <a:r>
-              <a:rPr>
-                <a:latin typeface="Times New Roman"/>
-              </a:rPr>
-              <a:t>Critical insight: transaction cost economics also warns that new governance has its own costs. Writing terms as code, auditing it and paying for the platform are transaction costs too, so the ledger pays off only where the monitoring cost saved is greater. That favours territories with frequent, standard payments and argues against encoding rare, heavily negotiated deals first.</a:t>
             </a:r>
           </a:p>
         </p:txBody>
@@ -1405,7 +1349,7 @@
               <a:rPr>
                 <a:latin typeface="Times New Roman"/>
               </a:rPr>
-              <a:t>Jensen and Meckling’s (1976) agency theory explains the benefit. Agency costs arise when a principal delegates decisions to an agent whose interests may differ. Removing discretion from payment calculation reduces that cost, and the $424 million in unmatched royalties on slide two is, beneath the figures, an example of it.</a:t>
+              <a:t>Jensen and Meckling’s (1976) agency theory explains the benefit. Agency costs arise when a principal delegates decisions to an agent whose interests may differ. Removing discretion from payment calculation reduces that cost, and the $424 million in unmatched royalties on slide two is, beneath the figures, an example of it. The theory is persuasive on discretion but incomplete: removing discretion helps routine payments, yet royalty disputes often arise from ambiguity in the terms, which code cannot resolve and may harden.</a:t>
             </a:r>
           </a:p>
           <a:p>
@@ -1429,15 +1373,7 @@
               <a:rPr>
                 <a:latin typeface="Times New Roman"/>
               </a:rPr>
-              <a:t>Hype Cycle: Gartner’s 2024 Hype Cycle for Web3 and Blockchain placed most blockchain technologies past the peak and sliding into the Trough of Disillusionment, with smart contracts entering it. That argues for a staged pilot, not a big-bang launch. Gartner may not publish another blockchain cycle; its 2025 emerging-technologies cycle covers tokenisation and smart contracts under programmable money, within Autonomous Business.</a:t>
-            </a:r>
-          </a:p>
-          <a:p>
-            <a:r>
-              <a:rPr>
-                <a:latin typeface="Times New Roman"/>
-              </a:rPr>
-              <a:t>Critical insight: agency theory is persuasive on discretion but incomplete. Removing discretion helps routine payments, yet royalty disputes often arise from ambiguity in the terms, which code cannot resolve and may harden. Gartner’s trough position supports caution for the same reason: the technology works, but the legal and business conditions around it are still maturing. The case therefore rests on narrow, well-defined payment rules, not on blockchain in general.</a:t>
+              <a:t>Hype Cycle: Gartner’s 2024 Hype Cycle for Web3 and Blockchain placed most blockchain technologies past the peak and sliding into the Trough of Disillusionment, with smart contracts entering it. That argues for a staged pilot, not a big-bang launch. Gartner may not publish another blockchain cycle; its 2025 emerging-technologies cycle covers tokenisation and smart contracts under programmable money, within Autonomous Business. The trough supports caution for the same reason as above: the technology works, but the legal and business conditions around it are still maturing, so the case rests on narrow, well-defined payment rules, not on blockchain in general.</a:t>
             </a:r>
           </a:p>
         </p:txBody>
@@ -1550,15 +1486,7 @@
               <a:rPr>
                 <a:latin typeface="Times New Roman"/>
               </a:rPr>
-              <a:t>Value chain (Porter, 1985): technology development changes because royalty rules become reviewed smart-contract code that Legal and engineers sign off together. Inbound logistics, receiving content and talent rights, changes because rights windows and payment terms are read from one shared record, not re-confirmed by hand in every territory.</a:t>
-            </a:r>
-          </a:p>
-          <a:p>
-            <a:r>
-              <a:rPr>
-                <a:latin typeface="Times New Roman"/>
-              </a:rPr>
-              <a:t>Critical insight: Porter’s value chain shows the benefit does not sit in one function; it spreads across activities, which is why a single named owner matters. Without one, each function optimises its own step and the ledger becomes a fourth record. The theory turns a technology choice into an organisational design choice.</a:t>
+              <a:t>Value chain (Porter, 1985): technology development changes because royalty rules become reviewed smart-contract code that Legal and engineers sign off together. Inbound logistics, receiving content and talent rights, changes because rights windows and payment terms are read from one shared record, not re-confirmed by hand in every territory. Porter’s framework shows the benefit spreads across activities, which is why one named owner matters: without one, each function optimises its own step and the ledger becomes a fourth record. It turns a technology choice into an organisational design choice.</a:t>
             </a:r>
           </a:p>
         </p:txBody>
@@ -1671,15 +1599,7 @@
               <a:rPr>
                 <a:latin typeface="Times New Roman"/>
               </a:rPr>
-              <a:t>My response is sequencing, not reassurance: a phased rollout starting in territories with clearer digital-contract rules, keeping personal data off the ledger, a pilot in one territory with Legal in the design team, and a standing legal review as territories are added. The written contract stays the master and the ledger executes it.</a:t>
-            </a:r>
-          </a:p>
-          <a:p>
-            <a:r>
-              <a:rPr>
-                <a:latin typeface="Times New Roman"/>
-              </a:rPr>
-              <a:t>Critical insight: the legal teams’ concerns show why this is not a technology project. Werbach and Cornell’s point means the ledger can only execute a contract that law already recognises. So Legal acts as a design authority, not a late reviewer, and its approval is the real gate for each new territory.</a:t>
+              <a:t>My response is sequencing, not reassurance: a phased rollout starting in territories with clearer digital-contract rules, keeping personal data off the ledger, a pilot in one territory with Legal in the design team, and a standing legal review as territories are added. The written contract stays the master and the ledger executes it. That follows from Werbach and Cornell: the ledger can only execute a contract that law already recognises, so Legal acts as design authority, not a late reviewer, and its approval is the real gate for each new territory.</a:t>
             </a:r>
           </a:p>
         </p:txBody>
@@ -1777,7 +1697,7 @@
               <a:rPr>
                 <a:latin typeface="Times New Roman"/>
               </a:rPr>
-              <a:t>Auditable royalty infrastructure serves two goals: talent trust (fewer disputes, faster payments, a record that shows fairness) and licensing agility. Apple TV+ has committed to expanding third-party licensing, with an executive hired in 2024 (9to5Mac, 2024). As counterparties and territories grow, it needs infrastructure that scales without disputes growing at the same rate, so the ledger is closer to a condition of that strategy than a bonus.</a:t>
+              <a:t>Auditable royalty infrastructure serves two goals: talent trust (fewer disputes, faster payments, a record that shows fairness) and licensing agility. Apple TV+ has committed to expanding third-party licensing, with an executive hired in 2024 (9to5Mac, 2024). As counterparties and territories grow, it needs infrastructure that scales without disputes growing at the same rate, so the ledger is closer to a condition of that strategy than a bonus. This is a resource-based claim, not a technology claim: accurate payments build a track record rivals cannot buy. But it cuts both ways, since one visible error damages trust faster than many correct payments build it, so the sign-off controls on slide eleven protect the strategy as well as the money.</a:t>
             </a:r>
           </a:p>
           <a:p>
@@ -1794,14 +1714,6 @@
                 <a:latin typeface="Times New Roman"/>
               </a:rPr>
               <a:t>One assumption needs testing: the ledger is a differentiator only while competitors lack it. Whether the advantage lasts is the next slide.</a:t>
-            </a:r>
-          </a:p>
-          <a:p>
-            <a:r>
-              <a:rPr>
-                <a:latin typeface="Times New Roman"/>
-              </a:rPr>
-              <a:t>Critical insight: the trust argument is a resource-based claim, not a technology claim. Accurate payments build a track record that rivals cannot buy. But the logic cuts both ways: one visible error damages trust faster than many correct payments build it, so the sign-off controls on slide eleven protect the strategic benefit as well as the money.</a:t>
             </a:r>
           </a:p>
         </p:txBody>
@@ -1899,7 +1811,7 @@
               <a:rPr>
                 <a:latin typeface="Times New Roman"/>
               </a:rPr>
-              <a:t>DiMaggio and Powell’s (1983) institutional isomorphism says organisations in a field converge through coercive, mimetic and normative pressure. Mimetic pressure would appear if a rival copied Apple TV+. Coercive pressure is possible if regulators, as in the Copyright Royalty Board cycle on slide two, require more transparency in royalty reporting.</a:t>
+              <a:t>DiMaggio and Powell’s (1983) institutional isomorphism says organisations in a field converge through coercive, mimetic and normative pressure. Mimetic pressure would appear if a rival copied Apple TV+. Coercive pressure is possible if regulators, as in the Copyright Royalty Board cycle on slide two, require more transparency in royalty reporting. Because the technology is easy to copy, only the organisation and the relationships can be a lasting source of advantage.</a:t>
             </a:r>
           </a:p>
           <a:p>
@@ -1915,15 +1827,7 @@
               <a:rPr>
                 <a:latin typeface="Times New Roman"/>
               </a:rPr>
-              <a:t>VRIO (Barney, 1991). Valuable: yes, fewer disputes. Rare: yes for now; my searches found no major video streamer running a rights ledger, only music-side efforts such as Spotify’s 2017 Mediachain purchase and vendor platforms such as Tech Mahindra’s bCRMS, but absence of evidence is not proof. Hard to imitate: the code is copyable, the payment history is not. Organised: a named owner and team are proposed on slide six, but dual sign-off and standing legal review are still needed. Verdict: the advantage is temporary until the organisation and trust are built.</a:t>
-            </a:r>
-          </a:p>
-          <a:p>
-            <a:r>
-              <a:rPr>
-                <a:latin typeface="Times New Roman"/>
-              </a:rPr>
-              <a:t>Critical insight: isomorphism and VRIO point the same way. Because the technology is easy to copy, only the organisation and the relationships can be a lasting source of advantage, which is why Organised is the weakest test today. Barney’s framework also assumes a stable resource; here the resource, a record of verified payments, grows with use, so the advantage depends on starting early and running without visible errors.</a:t>
+              <a:t>VRIO (Barney, 1991). Valuable: yes, fewer disputes. Rare: yes for now; my searches found no major video streamer running a rights ledger, only music-side efforts such as Spotify’s 2017 Mediachain purchase and vendor platforms such as Tech Mahindra’s bCRMS, but absence of evidence is not proof. Hard to imitate: the code is copyable, the payment history is not. Organised: a named owner and team are proposed on slide six, but dual sign-off and standing legal review are still needed, so this is the weakest test today. Barney’s framework assumes a stable resource; here the resource, a record of verified payments, grows with use, so the advantage depends on starting early and running without visible errors. Verdict: the advantage is temporary until the organisation and trust are built.</a:t>
             </a:r>
           </a:p>
         </p:txBody>

</xml_diff>

<commit_message>
Extend speaker notes to about 3300 words
Co-Authored-By: Claude Sonnet 5.5 <noreply@anthropic.com>
Claude-Session: https://claude.ai/code/session_01PRvXFuBN7ZYwDJRpkf6We3
</commit_message>
<xml_diff>
--- a/Ledger_of_Record_updated.pptx
+++ b/Ledger_of_Record_updated.pptx
@@ -754,6 +754,14 @@
               <a:t>Against the three guiding questions: on feasibility, the mechanism cuts real agency and monitoring costs but adds an encoding-risk point. On people and processes, legal and rights concerns are legitimate and need governance, not reassurance. On sustained advantage, the edge lies in accumulated trust and payment history, which Apple TV+ has to keep building. The conclusion is therefore conditional, not enthusiastic: the practical answer is a staged, governed pilot judged against a measured baseline, not a company-wide commitment.</a:t>
             </a:r>
           </a:p>
+          <a:p>
+            <a:r>
+              <a:rPr>
+                <a:latin typeface="Times New Roman"/>
+              </a:rPr>
+              <a:t>For Apple TV+ the next steps are concrete. First, baseline the current dispute rate and reconciliation cost. Second, choose one territory with clearer digital-contract rules and run the pilot with Legal in the design team. Third, judge it on fewer disputes, faster payments and legal sign-off, not on technical success alone, and only then extend to the next territory. The limits of this analysis are also worth stating: the evidence on competitors is thin, the Deloitte figures are cross-industry, and the music example is an analogy. That is why I frame the recommendation as a governed pilot with clear tests, not a guaranteed return.</a:t>
+            </a:r>
+          </a:p>
         </p:txBody>
       </p:sp>
       <p:sp>
@@ -1244,7 +1252,7 @@
               <a:rPr>
                 <a:latin typeface="Times New Roman"/>
               </a:rPr>
-              <a:t>Williamson’s (1979) transaction cost economics explains why this matters. Firms choose governance structures to minimise the cost of contracting under uncertainty, and a ledger can be read as a governance mechanism that cuts the cost of monitoring and enforcing multi-party agreements. Confirmation and monitoring are transaction costs, so automating the trigger changes how the agreement is governed, not just how fast it runs. New governance has its own costs, though: writing terms as code, auditing it and paying for the platform are transaction costs too. So the ledger pays off only where the monitoring cost saved is greater, which favours territories with frequent, standard payments and argues against encoding rare, heavily negotiated deals first.</a:t>
+              <a:t>Williamson’s (1979) transaction cost economics explains why this matters. Firms choose governance structures to minimise the cost of contracting under uncertainty, and a ledger can be read as a governance mechanism that cuts the cost of monitoring and enforcing multi-party agreements. Confirmation and monitoring are transaction costs, so automating the trigger changes how the agreement is governed, not just how fast it runs. New governance has its own costs, though: writing terms as code, auditing it and paying for the platform are transaction costs too. So the ledger pays off only where the monitoring cost saved is greater, which favours territories with frequent, standard payments and argues against encoding rare, heavily negotiated deals first. In practice the saving shows up as fewer manual confirmation steps per territory, which Apple TV+ can count.</a:t>
             </a:r>
           </a:p>
           <a:p>
@@ -1365,7 +1373,7 @@
               <a:rPr>
                 <a:latin typeface="Times New Roman"/>
               </a:rPr>
-              <a:t>Cost and skills evidence: Deloitte’s 2019 Global Blockchain Survey reports that 28% of executives cite uncertain return on investment and 28% a lack of in-house skills (figures from secondary coverage).</a:t>
+              <a:t>Cost and skills evidence: Deloitte’s 2019 Global Blockchain Survey reports that 28% of executives cite uncertain return on investment and 28% a lack of in-house skills (figures from secondary coverage). Cost and integration deserve the same scrutiny as the legal point: the ledger has to connect to existing contract-management and finance systems, otherwise it recreates the three-way reconciliation problem it was meant to remove. Skills matter because someone must translate legal terms into code, and the gap between lawyers and developers is where errors enter. The figures show these are common executive concerns, not special pleading for this case. So the benefits are real only if the limitations are managed, and each limitation maps to a control later in the briefing: sign-off for coding risk, phased rollout for enforceability, and a one-territory pilot to test integration cost.</a:t>
             </a:r>
           </a:p>
           <a:p>
@@ -1705,7 +1713,7 @@
               <a:rPr>
                 <a:latin typeface="Times New Roman"/>
               </a:rPr>
-              <a:t>Two links to strategy. Talent retention: originals draw people to the wider Services ecosystem, and creators who can verify every payment have less reason to take their next project elsewhere. Agility: if partners already trust the record, adding a platform or territory is a new trigger, not a new reconciliation.</a:t>
+              <a:t>Two links to strategy. Talent retention: originals draw people to the wider Services ecosystem, and creators who can verify every payment have less reason to take their next project elsewhere. Agility: if partners already trust the record, adding a platform or territory is a new trigger, not a new reconciliation. The test of this link is measurable: whether dispute counts fall and whether new territories and partners can be added faster.</a:t>
             </a:r>
           </a:p>
           <a:p>
@@ -1819,7 +1827,7 @@
               <a:rPr>
                 <a:latin typeface="Times New Roman"/>
               </a:rPr>
-              <a:t>The counterargument: talent already on Apple’s ledger has an established payment history and little reason to leave when a rival adopts similar technology. So the technology advantage may converge while the relationship advantage lasts longer. My claim is that the advantage is relationship-based and accumulated, not technology-based.</a:t>
+              <a:t>The counterargument: talent already on Apple’s ledger has an established payment history and little reason to leave when a rival adopts similar technology. So the technology advantage may converge while the relationship advantage lasts longer. My claim is that the advantage is relationship-based and accumulated, not technology-based. Trust is also asymmetric: talent will judge Apple TV+ on its worst payment, not its average one, so the relationship advantage is only as strong as the error controls on slide eleven. And a rival does not start from zero, because it can copy the design and learn from Apple TV+’s mistakes, which narrows the early-mover gap even while payment history stays harder to copy. For that reason I treat the ledger as the foundation of a relationship strategy, not as the competitive advantage in itself, and I would review the VRIO result each year as competitors move.</a:t>
             </a:r>
           </a:p>
           <a:p>

</xml_diff>

<commit_message>
Rewrite speaker notes in a simpler spoken style
Co-Authored-By: Claude Sonnet 5.5 <noreply@anthropic.com>
Claude-Session: https://claude.ai/code/session_01PRvXFuBN7ZYwDJRpkf6We3
</commit_message>
<xml_diff>
--- a/Ledger_of_Record_updated.pptx
+++ b/Ledger_of_Record_updated.pptx
@@ -525,7 +525,7 @@
               <a:rPr>
                 <a:latin typeface="Times New Roman"/>
               </a:rPr>
-              <a:t>I’m presenting as Apple TV+’s Digital Transformation Consultant. This briefing treats blockchain-based smart contracts as infrastructure for royalty accuracy, not as speculative technology. They give legal and rights teams a trust layer for talent and music licensing across territories. The main risk is regulatory and legal uncertainty, not technical feasibility.</a:t>
+              <a:t>I’m presenting as Apple TV+’s Digital Transformation Consultant. My question is simple: can blockchain-based smart contracts help Apple TV+ pay royalties accurately as it grows? I treat the technology as plumbing, not hype. It gives legal and rights teams a record they can trust. The real risk isn’t whether it works technically. It’s whether the law and the organisation are ready for it.</a:t>
             </a:r>
           </a:p>
           <a:p>
@@ -533,7 +533,7 @@
               <a:rPr>
                 <a:latin typeface="Times New Roman"/>
               </a:rPr>
-              <a:t>Roadmap: context and the royalty challenge; what the technology is in plain terms; three benefits and three limitations; impact on legal, rights and finance teams; strategic fit and lasting advantage; and finally risks, recommendations and takeaways.</a:t>
+              <a:t>I’ll start with the problem, then explain the technology in plain terms, then weigh the benefits and limits. After that I’ll look at the people involved, how it fits Apple’s strategy, and what I’d recommend.</a:t>
             </a:r>
           </a:p>
         </p:txBody>
@@ -622,7 +622,7 @@
               <a:rPr>
                 <a:latin typeface="Times New Roman"/>
               </a:rPr>
-              <a:t>Three separate risks, each with its own cause, owner and mitigation, though they interact.</a:t>
+              <a:t>There are three risks, each with its own cause and its own fix, but they affect each other.</a:t>
             </a:r>
           </a:p>
           <a:p>
@@ -630,7 +630,7 @@
               <a:rPr>
                 <a:latin typeface="Times New Roman"/>
               </a:rPr>
-              <a:t>Data privacy: ledger entries may hold commercially sensitive or personal data while some regimes give rights to correct or erase it, which clashes with immutability (European Parliament and Council, 2016; Finck, 2018). The mitigation is architectural: keep personal data off-chain and record only a verification hash.</a:t>
+              <a:t>The first is data privacy. Ledger entries can hold sensitive commercial data or personal data, and some laws let people correct or delete their data, which clashes with a ledger that can’t be changed (European Parliament and Council, 2016; Finck, 2018). The fix is in the design: keep personal data off the ledger and record only a verification hash.</a:t>
             </a:r>
           </a:p>
           <a:p>
@@ -638,7 +638,7 @@
               <a:rPr>
                 <a:latin typeface="Times New Roman"/>
               </a:rPr>
-              <a:t>Cross-border regulation: there is no settled international standard for enforcing smart-contract royalties. The mitigation is the phased rollout by territory from slide seven, starting where digital-contract law is clearer. This is the risk Apple TV+ cannot fully control, which is why rollout order matters.</a:t>
+              <a:t>The second is cross-border regulation. There is no settled international standard for enforcing smart-contract royalties. The fix is the phased rollout from slide seven, starting where digital-contract law is clearer. This is the risk Apple TV+ can’t fully control, which is why the order of rollout matters.</a:t>
             </a:r>
           </a:p>
           <a:p>
@@ -646,7 +646,7 @@
               <a:rPr>
                 <a:latin typeface="Times New Roman"/>
               </a:rPr>
-              <a:t>Smart-contract error is the most serious risk, linked to the encoding gap on slide five. A wrong term in code keeps paying the wrong party until someone notices. The control is mandatory legal and technical sign-off before go-live, plus a manual override and dispute freeze. The risks interact: an error is harder to correct on an immutable ledger, and correcting it may touch personal data, so the controls work as a set, with off-chain data, sign-off and a freeze each covering another’s gap. For Apple TV+ the practical test of these controls is whether a wrong payment can be found and stopped before it reaches talent, which is a process the pilot can rehearse before go-live.</a:t>
+              <a:t>The third is smart-contract error, and I think it’s the most serious. It connects to the coding gap on slide five. A wrong term in the code keeps paying the wrong party until someone notices. So I’d require legal and technical sign-off before go-live, plus a manual override and a dispute freeze. The risks interact. An error is harder to fix on a ledger that can’t be changed, and fixing it may involve personal data. So the controls work as a set: personal data kept off the ledger, sign-off, and a freeze, each covering a gap in the others. The practical test is whether Apple TV+ can find and stop a wrong payment before it reaches talent, and the pilot can rehearse that before go-live.</a:t>
             </a:r>
           </a:p>
         </p:txBody>
@@ -735,7 +735,7 @@
               <a:rPr>
                 <a:latin typeface="Times New Roman"/>
               </a:rPr>
-              <a:t>Slide two opened with a $424 million-scale problem and a choice: address royalty accuracy structurally, or keep absorbing dispute costs. My answer is yes, but only if the ledger is treated as a legal and organisational commitment, not a technical fix left to run alone.</a:t>
+              <a:t>Slide two started with a $424 million problem and a choice: fix royalty accuracy properly, or keep paying for disputes. My answer is yes, fix it, but only if the ledger is treated as a legal and organisational commitment, not a technical fix left to run on its own.</a:t>
             </a:r>
           </a:p>
           <a:p>
@@ -743,7 +743,7 @@
               <a:rPr>
                 <a:latin typeface="Times New Roman"/>
               </a:rPr>
-              <a:t>Three conditions. Enforceability needs the phased, jurisdiction-aware rollout from slide seven. Encoding risk needs the dual sign-off from slide eleven. And the advantage must be understood as relationship-based and time-limited, as argued on slide ten, because isomorphic pressure will push competitors towards similar systems.</a:t>
+              <a:t>That depends on three things. For enforceability, a phased rollout by jurisdiction, as on slide seven. For coding risk, dual sign-off, as on slide eleven. And for competitive advantage, we have to accept that it is relationship-based and time-limited, as on slide ten, because competitors will be pushed to follow.</a:t>
             </a:r>
           </a:p>
           <a:p>
@@ -751,7 +751,7 @@
               <a:rPr>
                 <a:latin typeface="Times New Roman"/>
               </a:rPr>
-              <a:t>Against the three guiding questions: on feasibility, the mechanism cuts real agency and monitoring costs but adds an encoding-risk point. On people and processes, legal and rights concerns are legitimate and need governance, not reassurance. On sustained advantage, the edge lies in accumulated trust and payment history, which Apple TV+ has to keep building. The conclusion is therefore conditional, not enthusiastic: the practical answer is a staged, governed pilot judged against a measured baseline, not a company-wide commitment.</a:t>
+              <a:t>Against the three questions I set at the start: on feasibility, the mechanism cuts real monitoring and agency costs but adds a coding risk. On people and processes, the concerns of legal and rights teams are legitimate, and they need governance, not reassurance. On lasting advantage, the edge is accumulated trust and payment history, which Apple TV+ has to keep building. So the conclusion is conditional, not enthusiastic.</a:t>
             </a:r>
           </a:p>
           <a:p>
@@ -759,7 +759,7 @@
               <a:rPr>
                 <a:latin typeface="Times New Roman"/>
               </a:rPr>
-              <a:t>For Apple TV+ the next steps are concrete. First, baseline the current dispute rate and reconciliation cost. Second, choose one territory with clearer digital-contract rules and run the pilot with Legal in the design team. Third, judge it on fewer disputes, faster payments and legal sign-off, not on technical success alone, and only then extend to the next territory. The limits of this analysis are also worth stating: the evidence on competitors is thin, the Deloitte figures are cross-industry, and the music example is an analogy. That is why I frame the recommendation as a governed pilot with clear tests, not a guaranteed return.</a:t>
+              <a:t>In practice, I’d do three things. Measure the current dispute rate and reconciliation cost. Pick one territory with clearer digital-contract rules and run the pilot with Legal in the design team. Then judge it on fewer disputes, faster payments and legal sign-off, not just technical success, before moving to the next territory. I should also be clear about the limits. The evidence on competitors is thin, the Deloitte figures cover many industries, and the music example is an analogy. That is why I recommend a governed pilot with clear tests, not a guaranteed return.</a:t>
             </a:r>
           </a:p>
         </p:txBody>
@@ -848,7 +848,7 @@
               <a:rPr>
                 <a:latin typeface="Times New Roman"/>
               </a:rPr>
-              <a:t>Three practical recommendations, each turning a theory used earlier into an action with an owner.</a:t>
+              <a:t>I have three recommendations, and each one turns a theory from earlier into something someone owns.</a:t>
             </a:r>
           </a:p>
           <a:p>
@@ -856,7 +856,7 @@
               <a:rPr>
                 <a:latin typeface="Times New Roman"/>
               </a:rPr>
-              <a:t>First, transaction cost economics supports a standing governance function that regularly reviews whether the system is still reducing contracting costs as Apple TV+ adds new territories and rights types. Second, agency theory supports mandatory dual sign-off, because it addresses the new agency risk created when contract terms are translated into code. Third, institutional isomorphism suggests the first-mover advantage is temporary by design, so Apple TV+ should invest in relationships, accumulated trust and verified payment history, not rely on the technology once competitors move. All three cost little compared with the technology, so they are where management effort changes the outcome.</a:t>
+              <a:t>First, set up a standing governance review. Transaction cost economics tells us to keep checking that the system still lowers contracting costs as new territories and rights types are added. Second, require dual sign-off before go-live. Agency theory warns that translating terms into code creates a new risk, and two sign-offs control it. Third, invest in relationships, not just technology. Institutional isomorphism says competitors will copy the technology, so the first-mover edge is temporary by design. What lasts is trust built through visible payment history and clear timelines. None of these costs much compared with the technology, and they are where management effort changes the outcome.</a:t>
             </a:r>
           </a:p>
         </p:txBody>
@@ -929,7 +929,7 @@
               <a:rPr>
                 <a:latin typeface="Times New Roman"/>
               </a:rPr>
-              <a:t>My answer is yes, legal and rights teams can be brought along, if Legal helps shape the design, a one-territory pilot proves the value, and people are trained before go-live.</a:t>
+              <a:t>My answer is yes, legal and rights teams can be brought along, but only if three things happen. Legal helps shape the design, a one-territory pilot proves the value, and people are trained before go-live.</a:t>
             </a:r>
           </a:p>
           <a:p>
@@ -937,7 +937,7 @@
               <a:rPr>
                 <a:latin typeface="Times New Roman"/>
               </a:rPr>
-              <a:t>TAM (Davis, 1989): usefulness comes from answering the concerns on slide seven, a verifiable record for regulators, the written contract kept as master, and no extra version of the truth. Ease of use is hurt by unfamiliar tools, coding and integration, and helped by plugging into current systems, no coding by users and a simple read-only view. TAM predicts adoption from usefulness and ease of use, but these teams carry personal accountability, so trust in the output matters as much as either, which is why the barrier box focuses on the ability to stop a payment.</a:t>
+              <a:t>I used Davis’s (1989) technology acceptance model, which says people adopt a tool if it seems useful and easy to use. The ledger will seem useful if it answers the worries from slide seven: a record they can show a regulator, the written contract kept as master, and no extra version of the truth. It will seem hard to use if it brings unfamiliar tools, coding and awkward system links, and easy if it plugs into current systems, needs no coding from users, and gives a simple read-only view. One more point. These teams carry personal accountability, so trust in the output matters as much as ease of use. That’s why I focus on their ability to stop a payment.</a:t>
             </a:r>
           </a:p>
           <a:p>
@@ -945,7 +945,7 @@
               <a:rPr>
                 <a:latin typeface="Times New Roman"/>
               </a:rPr>
-              <a:t>Kotter (1996) has eight steps; I use three in order. Step 2, guiding coalition: Legal, Rights Ops and Finance in the design team under one named owner. Step 6, short-term wins: pilot in one territory and share the results. Step 8, anchor in the culture: make the quarterly review permanent. Kotter’s model assumes a sponsor who can drive change; the named owner supplies that, and without one the pilot’s wins would not spread. A limit of both models is that they describe attitudes, not whether the law will accept the ledger.</a:t>
+              <a:t>For change, I used three of Kotter’s (1996) eight steps, in order. Step two, build a guiding coalition: Legal, Rights Ops and Finance sit in the design team under one named owner. Step six, create short-term wins: pilot in one territory and share the results. Step eight, anchor the change in the culture: make the quarterly review permanent. Kotter assumes there is a sponsor who can drive change, and the named owner is that person. Both models describe attitudes, though. Neither tells us whether the law will accept the ledger.</a:t>
             </a:r>
           </a:p>
           <a:p>
@@ -953,7 +953,7 @@
               <a:rPr>
                 <a:latin typeface="Times New Roman"/>
               </a:rPr>
-              <a:t>Barrier: legal and rights teams fear answering for a wrongly coded payment, reduced by dual sign-off, a manual override and a dispute freeze. Digital confidence: Legal, Rights Ops and Finance are trained before the pilot on how the record works, reading a smart-contract term, and when to freeze a payment.</a:t>
+              <a:t>The main barrier is fear of answering for a wrongly coded payment, so I’d use dual sign-off, a manual override and a dispute freeze. And I’d train Legal, Rights Ops and Finance before the pilot on how the record works, how to read a smart-contract term, and when to freeze a payment.</a:t>
             </a:r>
           </a:p>
         </p:txBody>
@@ -1026,7 +1026,7 @@
               <a:rPr>
                 <a:latin typeface="Times New Roman"/>
               </a:rPr>
-              <a:t>Apple TV+ is expanding. It clears music synchronisation rights for its scripted and unscripted programming and negotiates talent agreements across the same territories, and it hired a licensing executive in 2024 to expand distribution of its originals to third-party platforms (9to5Mac, 2024). Every new platform and territory adds counterparties and rights windows that Legal, Rights Operations and Finance reconcile mostly by hand. The strategic question is how Apple TV+ keeps royalty payments accurate and trusted as it grows, rather than absorbing disputes afterwards.</a:t>
+              <a:t>Apple TV+ is growing. It clears music rights for its shows and negotiates talent deals across the same territories, and in 2024 it hired a licensing executive to take its originals to other platforms (9to5Mac, 2024). Every new platform and territory adds more parties and more rights windows, and Legal, Rights Ops and Finance still reconcile most of this by hand. So the question is how Apple TV+ keeps payments accurate and trusted as it grows, instead of paying for disputes afterwards.</a:t>
             </a:r>
           </a:p>
           <a:p>
@@ -1034,7 +1034,7 @@
               <a:rPr>
                 <a:latin typeface="Times New Roman"/>
               </a:rPr>
-              <a:t>The music industry shows what happens when this goes wrong, so I use it as a supporting example. The Mechanical Licensing Collective holds over $424 million in historical unmatched streaming royalties, collected but never matched to the people owed it (Billboard, 2023). Sharp (2023) argues this is the visible symptom of manual matching across too many rights holders and territories. The figure comes from music mechanicals, so it shows the shape of the problem, not Apple TV+’s own loss; the transferable point is structural, that manual matching fails as parties multiply.</a:t>
+              <a:t>The music industry shows what can go wrong, so I use it as an example. The Mechanical Licensing Collective is holding over $424 million in streaming royalties that were collected but never matched to the people owed them (Billboard, 2023). Sharp (2023) argues this is what manual matching looks like when there are too many rights holders and territories. Of course, that is a music figure, not Apple TV+’s own loss. What carries over is the pattern: manual matching breaks down as the number of parties grows.</a:t>
             </a:r>
           </a:p>
           <a:p>
@@ -1042,7 +1042,7 @@
               <a:rPr>
                 <a:latin typeface="Times New Roman"/>
               </a:rPr>
-              <a:t>Disputes are slow to resolve too. The Copyright Royalty Board set a streaming rate in 2018, it was appealed within months, and it was not finalised until August 2023 (U.S. Copyright Royalty Board, 2023). A private cross-territory dispute has no comparable backstop.</a:t>
+              <a:t>Disputes also take a long time to settle. The Copyright Royalty Board set a streaming rate in 2018, it was appealed within months, and it wasn’t final until August 2023 (U.S. Copyright Royalty Board, 2023). A private dispute across several countries has no referee like that.</a:t>
             </a:r>
           </a:p>
           <a:p>
@@ -1050,7 +1050,7 @@
               <a:rPr>
                 <a:latin typeface="Times New Roman"/>
               </a:rPr>
-              <a:t>One objection: this is a music problem, not a film and TV one. It is not, because Apple TV+ clears music sync rights and talent agreements across the same territories, so the same many-parties, many-territories structure applies to both, and the exposure grows with the licensing expansion. The mechanism already exists elsewhere; what is open is how it is governed here. Apple TV+ should therefore measure its own dispute rate and reconciliation cost before any pilot, so a benefit claimed later can be tested against a baseline.</a:t>
+              <a:t>Someone might say this is a music problem, not a film and TV one. But Apple TV+ clears music rights and talent deals in the same territories, so the same structure applies, and it grows with the licensing plan. So before any pilot, Apple TV+ should measure its own dispute rate and reconciliation cost. Then any benefit we claim later can be checked against a real baseline.</a:t>
             </a:r>
           </a:p>
         </p:txBody>
@@ -1139,7 +1139,7 @@
               <a:rPr>
                 <a:latin typeface="Times New Roman"/>
               </a:rPr>
-              <a:t>A blockchain has three simple ideas. Blocks: each record is stored in a block linked to the one before, so altering an old record breaks the chain and is visible. Distributed copies: talent, rights holders and Apple TV+ each hold a copy, so no single administrator has to be taken on trust. Smart contract: licensing rules written as code, so when a rights window opens the royalty calculation and payment can start without manual checking.</a:t>
+              <a:t>I’ll keep the technology simple. A blockchain has three ideas. First, blocks. Each record sits in a block linked to the one before it, so if someone changes an old record, the chain breaks and everyone can see it. Second, shared copies. Talent, rights holders and Apple TV+ each hold a copy, so nobody has to simply trust one administrator. Third, the smart contract. The licensing rules are written as code, so when a rights window opens the royalty calculation and payment can start without someone checking by hand.</a:t>
             </a:r>
           </a:p>
           <a:p>
@@ -1147,7 +1147,7 @@
               <a:rPr>
                 <a:latin typeface="Times New Roman"/>
               </a:rPr>
-              <a:t>This is not just a rights database with more permissions. A conventional database makes every participant rely on whoever controls it, often one of the counterparties. A shared ledger lets each authorised party verify the record independently. Zhao and O’Mahony (2018) showed this for music rights with a working prototype, BMCProtector, and García et al. (2023) show research has moved from feasibility to the legal and business questions this briefing addresses. But a shared ledger only helps if counterparties actually join it, so its value depends on adoption by talent and rights holders, a relationship task as much as a technical one.</a:t>
+              <a:t>You might ask why this isn’t just a better rights database. The problem with a normal database is that everyone has to trust whoever runs it, and in a multi-party deal that is often one of the counterparties. A shared ledger lets each party check the record for themselves. Zhao and O’Mahony (2018) built a working prototype for music rights, so we know it can be done. García et al. (2023) say research has moved on from “does it work?” to the legal and business questions, which is where this briefing sits. But a shared ledger is only useful if the other parties actually join it. So its value depends on talent and rights holders taking part, which is as much a relationship job as a technical one.</a:t>
             </a:r>
           </a:p>
           <a:p>
@@ -1155,7 +1155,7 @@
               <a:rPr>
                 <a:latin typeface="Times New Roman"/>
               </a:rPr>
-              <a:t>Definition: Iansiti and Lakhani (2017) describe blockchain as an open, distributed ledger that records transactions between two parties in a verifiable and permanent way and can be programmed to trigger transactions automatically. They call it a foundational technology, like the internet, that takes years to transform markets rather than a quick disruption. That fits this case: Apple TV+ is not replacing a business model, it is changing how a record is shared.</a:t>
+              <a:t>For a definition, I’ll use Iansiti and Lakhani (2017): an open, distributed ledger that records transactions between two parties in a way that can be verified and can’t be changed, and that can be programmed to trigger transactions automatically. They call it a foundational technology, like the internet, which changes things slowly rather than overnight. That fits here. Apple TV+ isn’t replacing its business. It is changing how a record is shared.</a:t>
             </a:r>
           </a:p>
         </p:txBody>
@@ -1244,7 +1244,7 @@
               <a:rPr>
                 <a:latin typeface="Times New Roman"/>
               </a:rPr>
-              <a:t>The contract does not wait to be enforced; the trigger is built into the ledger. When a rights window opens in a territory, the royalty calculation and payment can begin then, rather than waiting for someone to check manually. For Apple TV+ the EU, APAC and US windows open on different dates, and each currently needs a confirmation and a payment step.</a:t>
+              <a:t>The key point is that the contract doesn’t wait for someone to enforce it. The trigger sits inside the ledger. When a rights window opens in a territory, the calculation and payment can start right then. At the moment, the EU, APAC and US windows open on different dates, and each one needs someone to confirm it and someone to pay it.</a:t>
             </a:r>
           </a:p>
           <a:p>
@@ -1252,7 +1252,7 @@
               <a:rPr>
                 <a:latin typeface="Times New Roman"/>
               </a:rPr>
-              <a:t>Williamson’s (1979) transaction cost economics explains why this matters. Firms choose governance structures to minimise the cost of contracting under uncertainty, and a ledger can be read as a governance mechanism that cuts the cost of monitoring and enforcing multi-party agreements. Confirmation and monitoring are transaction costs, so automating the trigger changes how the agreement is governed, not just how fast it runs. New governance has its own costs, though: writing terms as code, auditing it and paying for the platform are transaction costs too. So the ledger pays off only where the monitoring cost saved is greater, which favours territories with frequent, standard payments and argues against encoding rare, heavily negotiated deals first. In practice the saving shows up as fewer manual confirmation steps per territory, which Apple TV+ can count.</a:t>
+              <a:t>Williamson’s (1979) transaction cost economics helps explain why that matters. His idea is that firms organise a deal so that contracting costs stay low, including the cost of monitoring and enforcing it. Checking that a window has opened is a monitoring cost. So automating the trigger changes how the deal is governed, not just how fast it runs. But the theory cuts both ways. Writing terms as code, auditing the code and running the platform are costs too. So the ledger only pays off where the monitoring it saves is worth more than that. That points to territories with frequent, standard payments, and away from rare, heavily negotiated deals. In practice, Apple TV+ can count the saving as fewer manual confirmation steps per territory.</a:t>
             </a:r>
           </a:p>
           <a:p>
@@ -1260,7 +1260,7 @@
               <a:rPr>
                 <a:latin typeface="Times New Roman"/>
               </a:rPr>
-              <a:t>The limit: Williamson can show the ledger may govern more efficiently, but not that a court in every territory would treat an automatically executed payment as legally binding. That legal gap is central to the next stage of the argument.</a:t>
+              <a:t>There is one limit. Williamson can show the ledger may be a cheaper way to govern a deal. He can’t tell us whether a court in every country would accept an automatic payment as legally binding. That legal gap is what the next slides deal with.</a:t>
             </a:r>
           </a:p>
         </p:txBody>
@@ -1349,7 +1349,7 @@
               <a:rPr>
                 <a:latin typeface="Times New Roman"/>
               </a:rPr>
-              <a:t>Three benefits. Fewer payment errors and disputes, because automatic triggers remove discretion over when and how a royalty is paid. One auditable record that every party can verify, which cuts reconciliation effort. Faster payment that scales, because a new territory adds a trigger rather than a manual process. Three limitations: legal enforceability, cost and integration, and skills and coding risk.</a:t>
+              <a:t>Here are the benefits and the limits side by side. The benefits are fewer errors and disputes, because automatic triggers take away discretion over when and how royalties are paid; one record that everyone can audit; and faster payment that scales, because a new territory just adds a trigger. The limits are legal enforceability, cost and integration, and skills and coding risk.</a:t>
             </a:r>
           </a:p>
           <a:p>
@@ -1357,7 +1357,7 @@
               <a:rPr>
                 <a:latin typeface="Times New Roman"/>
               </a:rPr>
-              <a:t>Jensen and Meckling’s (1976) agency theory explains the benefit. Agency costs arise when a principal delegates decisions to an agent whose interests may differ. Removing discretion from payment calculation reduces that cost, and the $424 million in unmatched royalties on slide two is, beneath the figures, an example of it. The theory is persuasive on discretion but incomplete: removing discretion helps routine payments, yet royalty disputes often arise from ambiguity in the terms, which code cannot resolve and may harden.</a:t>
+              <a:t>Jensen and Meckling’s (1976) agency theory explains the first benefit. Agency costs appear when someone hands decisions to another party whose interests may differ. Taking discretion out of the payment calculation reduces that cost, and the $424 million on slide two is really an example of it. But the theory only goes so far. Removing discretion helps with routine payments. Many royalty disputes come from unclear terms, and code can’t fix unclear terms.</a:t>
             </a:r>
           </a:p>
           <a:p>
@@ -1365,7 +1365,7 @@
               <a:rPr>
                 <a:latin typeface="Times New Roman"/>
               </a:rPr>
-              <a:t>The main limitation is legal, not technical. Correct execution does not make a payment legally binding if a party disputes the underlying terms, so execution and enforceability are separate issues (Werbach and Cornell, 2017; Levy, 2017). Translating contract terms into code also creates a smaller new agency risk, which is why slide eleven needs a specific control. Net, it is an improvement but not cost-free.</a:t>
+              <a:t>The biggest limit is legal, not technical. A payment can execute correctly and still not be legally binding if someone disputes the underlying terms (Werbach and Cornell, 2017; Levy, 2017). Turning contract terms into code also creates a smaller new risk, because whoever translates them can make a mistake. That is why slide eleven has a specific control for it.</a:t>
             </a:r>
           </a:p>
           <a:p>
@@ -1373,7 +1373,7 @@
               <a:rPr>
                 <a:latin typeface="Times New Roman"/>
               </a:rPr>
-              <a:t>Cost and skills evidence: Deloitte’s 2019 Global Blockchain Survey reports that 28% of executives cite uncertain return on investment and 28% a lack of in-house skills (figures from secondary coverage). Cost and integration deserve the same scrutiny as the legal point: the ledger has to connect to existing contract-management and finance systems, otherwise it recreates the three-way reconciliation problem it was meant to remove. Skills matter because someone must translate legal terms into code, and the gap between lawyers and developers is where errors enter. The figures show these are common executive concerns, not special pleading for this case. So the benefits are real only if the limitations are managed, and each limitation maps to a control later in the briefing: sign-off for coding risk, phased rollout for enforceability, and a one-territory pilot to test integration cost.</a:t>
+              <a:t>On cost and skills, Deloitte’s 2019 Global Blockchain Survey found that 28% of executives cite uncertain return on investment and 28% cite a lack of in-house skills (I took these figures from secondary coverage). They matter for Apple TV+ too. The ledger has to connect to the contract and finance systems already in use, or it just becomes a fourth record. And someone has to translate legal terms into code, which is where lawyers and developers can talk past each other. So each limit needs an answer, and the later slides give one: sign-off for the coding risk, a phased rollout for enforceability, and a one-territory pilot to test integration.</a:t>
             </a:r>
           </a:p>
           <a:p>
@@ -1381,7 +1381,7 @@
               <a:rPr>
                 <a:latin typeface="Times New Roman"/>
               </a:rPr>
-              <a:t>Hype Cycle: Gartner’s 2024 Hype Cycle for Web3 and Blockchain placed most blockchain technologies past the peak and sliding into the Trough of Disillusionment, with smart contracts entering it. That argues for a staged pilot, not a big-bang launch. Gartner may not publish another blockchain cycle; its 2025 emerging-technologies cycle covers tokenisation and smart contracts under programmable money, within Autonomous Business. The trough supports caution for the same reason as above: the technology works, but the legal and business conditions around it are still maturing, so the case rests on narrow, well-defined payment rules, not on blockchain in general.</a:t>
+              <a:t>Finally, timing. Gartner’s 2024 Hype Cycle for Web3 and Blockchain put most blockchain technologies past the peak and sliding into the Trough of Disillusionment, with smart contracts just entering it. For Apple TV+ that means a staged pilot, not a big launch. Gartner may not publish another blockchain cycle, and its 2025 emerging-technologies cycle covers tokenisation and smart contracts under programmable money, as part of Autonomous Business. The technology works, but the legal and business setting is still maturing, so the case rests on narrow, well-defined payment rules, not on blockchain in general.</a:t>
             </a:r>
           </a:p>
         </p:txBody>
@@ -1470,7 +1470,7 @@
               <a:rPr>
                 <a:latin typeface="Times New Roman"/>
               </a:rPr>
-              <a:t>Three functions keep three versions of the same royalty information. Legal holds contract terms, Rights Operations holds territory and window status, and Finance holds the payment record, reconciled only periodically. A shared ledger does not just speed up that cross-check; it removes much of the need for it.</a:t>
+              <a:t>Right now, three teams each keep their own version of the same royalty information. Legal holds the contract terms, Rights Ops tracks territories and windows, and Finance holds the payments. They only check against each other from time to time. A shared ledger doesn’t just make that check faster. It removes most of the need for it.</a:t>
             </a:r>
           </a:p>
           <a:p>
@@ -1478,7 +1478,7 @@
               <a:rPr>
                 <a:latin typeface="Times New Roman"/>
               </a:rPr>
-              <a:t>The work changes, not only its speed. Legal moves from after-the-event compliance review to verifying terms as they are encoded. Rights Ops moves from chasing confirmation that a window has opened to monitoring ledger triggers. Finance moves from reconciling disputed claims to auditing a record that is reconciled by design. That is a real shift in skills and workflows, so the concerns on the next slide are not simple resistance to change.</a:t>
+              <a:t>The work itself changes, not only the speed. Legal stops reviewing after the event and starts checking terms as they are written into the system. Rights Ops stops chasing people to confirm a window has opened and watches the ledger triggers instead. Finance stops sorting out disputed claims and audits a record that is already reconciled. That is a real change in skills, so the worries on the next slide aren’t just resistance to change.</a:t>
             </a:r>
           </a:p>
           <a:p>
@@ -1486,7 +1486,7 @@
               <a:rPr>
                 <a:latin typeface="Times New Roman"/>
               </a:rPr>
-              <a:t>Structure and culture: one small cross-functional rights-ledger team with a named owner replaces three reconciliations, and each team moves to verifying as terms are encoded, which needs training, shared accountability and trust in a record they did not create.</a:t>
+              <a:t>On structure and culture, I’d form one small team with a single named owner in place of three separate reconciliations. Culturally, people have to trust a record they didn’t create themselves, and that takes training and shared accountability.</a:t>
             </a:r>
           </a:p>
           <a:p>
@@ -1494,7 +1494,7 @@
               <a:rPr>
                 <a:latin typeface="Times New Roman"/>
               </a:rPr>
-              <a:t>Value chain (Porter, 1985): technology development changes because royalty rules become reviewed smart-contract code that Legal and engineers sign off together. Inbound logistics, receiving content and talent rights, changes because rights windows and payment terms are read from one shared record, not re-confirmed by hand in every territory. Porter’s framework shows the benefit spreads across activities, which is why one named owner matters: without one, each function optimises its own step and the ledger becomes a fourth record. It turns a technology choice into an organisational design choice.</a:t>
+              <a:t>I also used Porter’s (1985) value chain to see where the ledger bites. In technology development, royalty rules become tested code that Legal and engineers sign off together. In inbound logistics, which for a streamer means receiving content and talent rights, windows and payment terms come from one shared record instead of being re-confirmed by hand in each territory. Porter’s point is that the benefit is spread across activities, which is why one named owner matters. Without one, each function improves its own step and the ledger becomes a fourth record. So this is really an organisational design choice, not only a technology choice.</a:t>
             </a:r>
           </a:p>
         </p:txBody>
@@ -1583,7 +1583,7 @@
               <a:rPr>
                 <a:latin typeface="Times New Roman"/>
               </a:rPr>
-              <a:t>I focus on legal and rights teams. They are not resistant by habit; they would answer to a regulator or court if something went wrong, so their concerns are professional.</a:t>
+              <a:t>I focus on legal and rights teams. They aren’t against change by habit. They are the people who would have to answer to a regulator or a court if something went wrong, so their concerns are professional ones.</a:t>
             </a:r>
           </a:p>
           <a:p>
@@ -1591,7 +1591,7 @@
               <a:rPr>
                 <a:latin typeface="Times New Roman"/>
               </a:rPr>
-              <a:t>Regulatory uncertainty: which country’s law governs a cross-border smart-contract payment dispute, and an immutable ledger can clash with GDPR rights to rectify or erase personal data (European Parliament and Council, 2016; Finck, 2018). Enforceability: correct execution does not guarantee a binding payment, and Werbach and Cornell (2017) and Levy (2017) both argue smart contracts do not replace contract law. Integration: the ledger must work with existing contract and finance systems, or it recreates the three-way reconciliation problem.</a:t>
+              <a:t>They have three. The first is regulation: which country’s law applies to a cross-border smart-contract payment dispute, and an unchangeable ledger can clash with GDPR rights to correct or delete personal data (European Parliament and Council, 2016; Finck, 2018). The second is enforceability. Correct execution doesn’t guarantee a binding payment, and Werbach and Cornell (2017) and Levy (2017) both argue that smart contracts don’t replace contract law. The third is integration. The ledger has to work with the contract and finance systems already in use, or it recreates the three-way reconciliation problem.</a:t>
             </a:r>
           </a:p>
           <a:p>
@@ -1599,7 +1599,7 @@
               <a:rPr>
                 <a:latin typeface="Times New Roman"/>
               </a:rPr>
-              <a:t>The underlying barrier is the lack of settled case law and guidance on smart-contract royalty enforcement. Legal teams are being asked to approve a mechanism the law has not caught up with.</a:t>
+              <a:t>Underneath all three is the same gap: there is little settled case law on smart-contract royalties. Legal teams are being asked to approve something the law hasn’t caught up with.</a:t>
             </a:r>
           </a:p>
           <a:p>
@@ -1607,7 +1607,7 @@
               <a:rPr>
                 <a:latin typeface="Times New Roman"/>
               </a:rPr>
-              <a:t>My response is sequencing, not reassurance: a phased rollout starting in territories with clearer digital-contract rules, keeping personal data off the ledger, a pilot in one territory with Legal in the design team, and a standing legal review as territories are added. The written contract stays the master and the ledger executes it. That follows from Werbach and Cornell: the ledger can only execute a contract that law already recognises, so Legal acts as design authority, not a late reviewer, and its approval is the real gate for each new territory.</a:t>
+              <a:t>So my answer is about sequencing, not reassurance. Start in territories where digital-contract rules are clearer, keep personal data off the ledger, pilot in one territory with Legal in the design team, and keep a standing legal review as territories are added. The written contract stays the master and the ledger just carries it out. That follows from Werbach and Cornell: the ledger can only run a contract the law already recognises. So Legal should be a design authority, not a late reviewer, and its approval is the real gate for each new territory.</a:t>
             </a:r>
           </a:p>
         </p:txBody>
@@ -1697,7 +1697,7 @@
               <a:rPr>
                 <a:latin typeface="Times New Roman"/>
               </a:rPr>
-              <a:t>Every verified payment builds talent trust, and that trust is tied to licensing agility. If rights holders see accurate, timely, traceable payments, they have less reason to hesitate over future agreements.</a:t>
+              <a:t>The idea on this slide is simple. Every verified payment is a small deposit of trust with talent, and that trust is tied to how quickly Apple TV+ can license. If rights holders see payments that are accurate, on time and traceable, they have less reason to hesitate over the next deal.</a:t>
             </a:r>
           </a:p>
           <a:p>
@@ -1705,7 +1705,7 @@
               <a:rPr>
                 <a:latin typeface="Times New Roman"/>
               </a:rPr>
-              <a:t>Auditable royalty infrastructure serves two goals: talent trust (fewer disputes, faster payments, a record that shows fairness) and licensing agility. Apple TV+ has committed to expanding third-party licensing, with an executive hired in 2024 (9to5Mac, 2024). As counterparties and territories grow, it needs infrastructure that scales without disputes growing at the same rate, so the ledger is closer to a condition of that strategy than a bonus. This is a resource-based claim, not a technology claim: accurate payments build a track record rivals cannot buy. But it cuts both ways, since one visible error damages trust faster than many correct payments build it, so the sign-off controls on slide eleven protect the strategy as well as the money.</a:t>
+              <a:t>This ties to Apple’s strategy. Apple TV+ has committed to expanding third-party licensing, with an executive hired in 2024 (9to5Mac, 2024). As partners and territories grow, it needs a system that scales without disputes growing at the same rate. That makes the ledger more a condition of the strategy than a bonus. There are two links. On talent retention, originals draw people into the wider Services ecosystem, and creators who can verify every payment have less reason to take their next project elsewhere. On agility, if partners already trust the record, adding a platform or a territory means adding a trigger, not starting a new reconciliation.</a:t>
             </a:r>
           </a:p>
           <a:p>
@@ -1713,7 +1713,7 @@
               <a:rPr>
                 <a:latin typeface="Times New Roman"/>
               </a:rPr>
-              <a:t>Two links to strategy. Talent retention: originals draw people to the wider Services ecosystem, and creators who can verify every payment have less reason to take their next project elsewhere. Agility: if partners already trust the record, adding a platform or territory is a new trigger, not a new reconciliation. The test of this link is measurable: whether dispute counts fall and whether new territories and partners can be added faster.</a:t>
+              <a:t>I’d call this a resource-based argument rather than a technology one. Accurate payments build a track record that rivals can’t simply buy. But it cuts both ways. One visible error damages trust faster than many correct payments build it. So the sign-off controls on slide eleven protect the strategy as well as the money. And the link can be tested: do dispute numbers fall, and can new territories and partners be added faster?</a:t>
             </a:r>
           </a:p>
           <a:p>
@@ -1721,7 +1721,7 @@
               <a:rPr>
                 <a:latin typeface="Times New Roman"/>
               </a:rPr>
-              <a:t>One assumption needs testing: the ledger is a differentiator only while competitors lack it. Whether the advantage lasts is the next slide.</a:t>
+              <a:t>One assumption needs checking. The ledger is only a differentiator while competitors don’t have one. Whether the advantage lasts is the next slide.</a:t>
             </a:r>
           </a:p>
         </p:txBody>
@@ -1811,7 +1811,7 @@
               <a:rPr>
                 <a:latin typeface="Times New Roman"/>
               </a:rPr>
-              <a:t>Being early is real, but staying ahead is a separate claim, and the evidence does not support it without qualification.</a:t>
+              <a:t>Being early is a real advantage, but staying ahead is a different claim, and I don’t think the evidence supports it without qualification.</a:t>
             </a:r>
           </a:p>
           <a:p>
@@ -1819,7 +1819,7 @@
               <a:rPr>
                 <a:latin typeface="Times New Roman"/>
               </a:rPr>
-              <a:t>DiMaggio and Powell’s (1983) institutional isomorphism says organisations in a field converge through coercive, mimetic and normative pressure. Mimetic pressure would appear if a rival copied Apple TV+. Coercive pressure is possible if regulators, as in the Copyright Royalty Board cycle on slide two, require more transparency in royalty reporting. Because the technology is easy to copy, only the organisation and the relationships can be a lasting source of advantage.</a:t>
+              <a:t>DiMaggio and Powell’s (1983) institutional isomorphism says organisations in the same field become more alike over time, through pressure from regulators, copying under uncertainty, and professional norms. Copying could happen if a rival simply follows Apple TV+. Regulators could also push for more transparent royalty reporting, as the Copyright Royalty Board cycle on slide two suggests. Since the technology is easy to copy, only the organisation and the relationships can be a lasting source of advantage.</a:t>
             </a:r>
           </a:p>
           <a:p>
@@ -1827,7 +1827,7 @@
               <a:rPr>
                 <a:latin typeface="Times New Roman"/>
               </a:rPr>
-              <a:t>The counterargument: talent already on Apple’s ledger has an established payment history and little reason to leave when a rival adopts similar technology. So the technology advantage may converge while the relationship advantage lasts longer. My claim is that the advantage is relationship-based and accumulated, not technology-based. Trust is also asymmetric: talent will judge Apple TV+ on its worst payment, not its average one, so the relationship advantage is only as strong as the error controls on slide eleven. And a rival does not start from zero, because it can copy the design and learn from Apple TV+’s mistakes, which narrows the early-mover gap even while payment history stays harder to copy. For that reason I treat the ledger as the foundation of a relationship strategy, not as the competitive advantage in itself, and I would review the VRIO result each year as competitors move.</a:t>
+              <a:t>There is a fair counterargument. Talent already on Apple’s ledger has a payment history and little reason to leave just because a rival adopts something similar. So the technology advantage may fade while the relationship advantage lasts longer. That is my claim: the advantage is built on relationships and builds up over time. It is not built on technology. Trust is also lopsided. Talent will judge Apple TV+ on its worst payment, not its average one, so the advantage is only as strong as the error controls on slide eleven. So I treat the ledger as the foundation of a relationship strategy, not the advantage itself, and I’d review this every year.</a:t>
             </a:r>
           </a:p>
           <a:p>
@@ -1835,7 +1835,7 @@
               <a:rPr>
                 <a:latin typeface="Times New Roman"/>
               </a:rPr>
-              <a:t>VRIO (Barney, 1991). Valuable: yes, fewer disputes. Rare: yes for now; my searches found no major video streamer running a rights ledger, only music-side efforts such as Spotify’s 2017 Mediachain purchase and vendor platforms such as Tech Mahindra’s bCRMS, but absence of evidence is not proof. Hard to imitate: the code is copyable, the payment history is not. Organised: a named owner and team are proposed on slide six, but dual sign-off and standing legal review are still needed, so this is the weakest test today. Barney’s framework assumes a stable resource; here the resource, a record of verified payments, grows with use, so the advantage depends on starting early and running without visible errors. Verdict: the advantage is temporary until the organisation and trust are built.</a:t>
+              <a:t>Using Barney’s (1991) VRIO test: is it valuable? Yes, mainly because it means fewer disputes. Is it rare? Yes, for now. My searches found no major video streamer running a rights ledger, only music efforts such as Spotify’s 2017 purchase of Mediachain and vendor platforms like Tech Mahindra’s bCRMS. That isn’t proof that none exist. Is it hard to imitate? The code is easy to copy. The payment history isn’t. Is Apple TV+ organised to capture it? Not yet. A named owner and team are proposed on slide six, but dual sign-off and a standing legal review still need to be set up, so this is the weakest test today. Barney assumes a stable resource, but here the record of payments grows with use, so the advantage depends on starting early and running without visible errors. My verdict: the advantage is temporary until the organisation and the trust are built.</a:t>
             </a:r>
           </a:p>
         </p:txBody>

</xml_diff>

<commit_message>
Rewrite notes in the third person and remove first and second person from slide text
Co-Authored-By: Claude Sonnet 5.5 <noreply@anthropic.com>
Claude-Session: https://claude.ai/code/session_01PRvXFuBN7ZYwDJRpkf6We3
</commit_message>
<xml_diff>
--- a/Ledger_of_Record_updated.pptx
+++ b/Ledger_of_Record_updated.pptx
@@ -525,7 +525,7 @@
               <a:rPr>
                 <a:latin typeface="Times New Roman"/>
               </a:rPr>
-              <a:t>I’m presenting as Apple TV+’s Digital Transformation Consultant. My question is simple: can blockchain-based smart contracts help Apple TV+ pay royalties accurately as it grows? I treat the technology as plumbing, not hype. It gives legal and rights teams a record they can trust. The real risk isn’t whether it works technically. It’s whether the law and the organisation are ready for it.</a:t>
+              <a:t>This briefing is presented from the perspective of Apple TV+’s Digital Transformation Consultant. The central question is whether blockchain-based smart contracts can help Apple TV+ pay royalties accurately as it grows. The technology is treated as infrastructure, not hype: it gives legal and rights teams a record they can trust. The real risk is not whether it works technically, but whether the law and the organisation are ready for it.</a:t>
             </a:r>
           </a:p>
           <a:p>
@@ -533,7 +533,7 @@
               <a:rPr>
                 <a:latin typeface="Times New Roman"/>
               </a:rPr>
-              <a:t>I’ll start with the problem, then explain the technology in plain terms, then weigh the benefits and limits. After that I’ll look at the people involved, how it fits Apple’s strategy, and what I’d recommend.</a:t>
+              <a:t>The briefing begins with the problem, then explains the technology in plain terms and weighs the benefits and limits. It then covers the people involved, the fit with Apple’s strategy, and the recommendations.</a:t>
             </a:r>
           </a:p>
         </p:txBody>
@@ -630,7 +630,7 @@
               <a:rPr>
                 <a:latin typeface="Times New Roman"/>
               </a:rPr>
-              <a:t>The first is data privacy. Ledger entries can hold sensitive commercial data or personal data, and some laws let people correct or delete their data, which clashes with a ledger that can’t be changed (European Parliament and Council, 2016; Finck, 2018). The fix is in the design: keep personal data off the ledger and record only a verification hash.</a:t>
+              <a:t>The first is data privacy. Ledger entries can hold sensitive commercial data or personal data, and some laws let people correct or delete their data, which clashes with a ledger that cannot be changed (European Parliament and Council, 2016; Finck, 2018). The fix is in the design: keep personal data off the ledger and record only a verification hash.</a:t>
             </a:r>
           </a:p>
           <a:p>
@@ -638,7 +638,7 @@
               <a:rPr>
                 <a:latin typeface="Times New Roman"/>
               </a:rPr>
-              <a:t>The second is cross-border regulation. There is no settled international standard for enforcing smart-contract royalties. The fix is the phased rollout from slide seven, starting where digital-contract law is clearer. This is the risk Apple TV+ can’t fully control, which is why the order of rollout matters.</a:t>
+              <a:t>The second is cross-border regulation. There is no settled international standard for enforcing smart-contract royalties. The fix is the phased rollout from slide seven, starting where digital-contract law is clearer. This is the risk Apple TV+ cannot fully control, which is why the order of rollout matters.</a:t>
             </a:r>
           </a:p>
           <a:p>
@@ -646,7 +646,7 @@
               <a:rPr>
                 <a:latin typeface="Times New Roman"/>
               </a:rPr>
-              <a:t>The third is smart-contract error, and I think it’s the most serious. It connects to the coding gap on slide five. A wrong term in the code keeps paying the wrong party until someone notices. So I’d require legal and technical sign-off before go-live, plus a manual override and a dispute freeze. The risks interact. An error is harder to fix on a ledger that can’t be changed, and fixing it may involve personal data. So the controls work as a set: personal data kept off the ledger, sign-off, and a freeze, each covering a gap in the others. The practical test is whether Apple TV+ can find and stop a wrong payment before it reaches talent, and the pilot can rehearse that before go-live.</a:t>
+              <a:t>The third is smart-contract error, and it is the most serious. It connects to the coding gap on slide five. A wrong term in the code keeps paying the wrong party until someone notices, so legal and technical sign-off should be required before go-live, together with a manual override and a dispute freeze. The risks interact. An error is harder to fix on a ledger that cannot be changed, and fixing it may involve personal data. The controls therefore work as a set: personal data kept off the ledger, sign-off, and a freeze, each covering a gap in the others. The practical test is whether Apple TV+ can find and stop a wrong payment before it reaches talent, and the pilot can rehearse that before go-live.</a:t>
             </a:r>
           </a:p>
         </p:txBody>
@@ -735,7 +735,7 @@
               <a:rPr>
                 <a:latin typeface="Times New Roman"/>
               </a:rPr>
-              <a:t>Slide two started with a $424 million problem and a choice: fix royalty accuracy properly, or keep paying for disputes. My answer is yes, fix it, but only if the ledger is treated as a legal and organisational commitment, not a technical fix left to run on its own.</a:t>
+              <a:t>Slide two started with a $424 million problem and a choice: fix royalty accuracy properly, or keep paying for disputes. The answer is yes, fix it, but only if the ledger is treated as a legal and organisational commitment, not a technical fix left to run on its own.</a:t>
             </a:r>
           </a:p>
           <a:p>
@@ -743,7 +743,7 @@
               <a:rPr>
                 <a:latin typeface="Times New Roman"/>
               </a:rPr>
-              <a:t>That depends on three things. For enforceability, a phased rollout by jurisdiction, as on slide seven. For coding risk, dual sign-off, as on slide eleven. And for competitive advantage, we have to accept that it is relationship-based and time-limited, as on slide ten, because competitors will be pushed to follow.</a:t>
+              <a:t>That depends on three things. For enforceability, a phased rollout by jurisdiction, as on slide seven. For coding risk, dual sign-off, as on slide eleven. And for competitive advantage, it has to be accepted that the advantage is relationship-based and time-limited, as on slide ten, because competitors will be pushed to follow.</a:t>
             </a:r>
           </a:p>
           <a:p>
@@ -751,7 +751,7 @@
               <a:rPr>
                 <a:latin typeface="Times New Roman"/>
               </a:rPr>
-              <a:t>Against the three questions I set at the start: on feasibility, the mechanism cuts real monitoring and agency costs but adds a coding risk. On people and processes, the concerns of legal and rights teams are legitimate, and they need governance, not reassurance. On lasting advantage, the edge is accumulated trust and payment history, which Apple TV+ has to keep building. So the conclusion is conditional, not enthusiastic.</a:t>
+              <a:t>Against the three questions set at the start: on feasibility, the mechanism cuts real monitoring and agency costs but adds a coding risk. On people and processes, the concerns of legal and rights teams are legitimate, and they need governance, not reassurance. On lasting advantage, the edge is accumulated trust and payment history, which Apple TV+ has to keep building. The conclusion is therefore conditional, not enthusiastic.</a:t>
             </a:r>
           </a:p>
           <a:p>
@@ -759,7 +759,7 @@
               <a:rPr>
                 <a:latin typeface="Times New Roman"/>
               </a:rPr>
-              <a:t>In practice, I’d do three things. Measure the current dispute rate and reconciliation cost. Pick one territory with clearer digital-contract rules and run the pilot with Legal in the design team. Then judge it on fewer disputes, faster payments and legal sign-off, not just technical success, before moving to the next territory. I should also be clear about the limits. The evidence on competitors is thin, the Deloitte figures cover many industries, and the music example is an analogy. That is why I recommend a governed pilot with clear tests, not a guaranteed return.</a:t>
+              <a:t>In practice, three steps follow. First, measure the current dispute rate and reconciliation cost. Second, pick one territory with clearer digital-contract rules and run the pilot with Legal in the design team. Third, judge it on fewer disputes, faster payments and legal sign-off, not just technical success, before moving to the next territory. The limits of the analysis should also be clear. The evidence on competitors is thin, the Deloitte figures cover many industries, and the music example is an analogy. That is why a governed pilot with clear tests is recommended, not a guaranteed return.</a:t>
             </a:r>
           </a:p>
         </p:txBody>
@@ -848,7 +848,7 @@
               <a:rPr>
                 <a:latin typeface="Times New Roman"/>
               </a:rPr>
-              <a:t>I have three recommendations, and each one turns a theory from earlier into something someone owns.</a:t>
+              <a:t>There are three recommendations, and each one turns a theory from earlier into something with an owner.</a:t>
             </a:r>
           </a:p>
           <a:p>
@@ -856,7 +856,7 @@
               <a:rPr>
                 <a:latin typeface="Times New Roman"/>
               </a:rPr>
-              <a:t>First, set up a standing governance review. Transaction cost economics tells us to keep checking that the system still lowers contracting costs as new territories and rights types are added. Second, require dual sign-off before go-live. Agency theory warns that translating terms into code creates a new risk, and two sign-offs control it. Third, invest in relationships, not just technology. Institutional isomorphism says competitors will copy the technology, so the first-mover edge is temporary by design. What lasts is trust built through visible payment history and clear timelines. None of these costs much compared with the technology, and they are where management effort changes the outcome.</a:t>
+              <a:t>First, set up a standing governance review. Transaction cost economics says to keep checking that the system still lowers contracting costs as new territories and rights types are added. Second, require dual sign-off before go-live. Agency theory warns that translating terms into code creates a new risk, and two sign-offs control it. Third, invest in relationships, not just technology. Institutional isomorphism says competitors will copy the technology, so the first-mover edge is temporary by design. What lasts is trust built through visible payment history and clear timelines. None of these costs much compared with the technology, and they are where management effort changes the outcome.</a:t>
             </a:r>
           </a:p>
         </p:txBody>
@@ -929,7 +929,7 @@
               <a:rPr>
                 <a:latin typeface="Times New Roman"/>
               </a:rPr>
-              <a:t>My answer is yes, legal and rights teams can be brought along, but only if three things happen. Legal helps shape the design, a one-territory pilot proves the value, and people are trained before go-live.</a:t>
+              <a:t>The answer is yes, legal and rights teams can be brought along, but only if three things happen. Legal helps shape the design, a one-territory pilot proves the value, and people are trained before go-live.</a:t>
             </a:r>
           </a:p>
           <a:p>
@@ -937,7 +937,7 @@
               <a:rPr>
                 <a:latin typeface="Times New Roman"/>
               </a:rPr>
-              <a:t>I used Davis’s (1989) technology acceptance model, which says people adopt a tool if it seems useful and easy to use. The ledger will seem useful if it answers the worries from slide seven: a record they can show a regulator, the written contract kept as master, and no extra version of the truth. It will seem hard to use if it brings unfamiliar tools, coding and awkward system links, and easy if it plugs into current systems, needs no coding from users, and gives a simple read-only view. One more point. These teams carry personal accountability, so trust in the output matters as much as ease of use. That’s why I focus on their ability to stop a payment.</a:t>
+              <a:t>Davis’s (1989) technology acceptance model says people adopt a tool if it seems useful and easy to use. The ledger will seem useful if it answers the concerns from slide seven: a record that can be shown to a regulator, the written contract kept as master, and no extra version of the truth. It will seem hard to use if it brings unfamiliar tools, coding and awkward system links, and easy if it plugs into current systems, needs no coding from users, and gives a simple read-only view. One more point is that these teams carry personal accountability, so trust in the output matters as much as ease of use. That is why the barrier box focuses on the ability to stop a payment.</a:t>
             </a:r>
           </a:p>
           <a:p>
@@ -945,7 +945,7 @@
               <a:rPr>
                 <a:latin typeface="Times New Roman"/>
               </a:rPr>
-              <a:t>For change, I used three of Kotter’s (1996) eight steps, in order. Step two, build a guiding coalition: Legal, Rights Ops and Finance sit in the design team under one named owner. Step six, create short-term wins: pilot in one territory and share the results. Step eight, anchor the change in the culture: make the quarterly review permanent. Kotter assumes there is a sponsor who can drive change, and the named owner is that person. Both models describe attitudes, though. Neither tells us whether the law will accept the ledger.</a:t>
+              <a:t>For change, three of Kotter’s (1996) eight steps are used, in order. Step two, build a guiding coalition: Legal, Rights Ops and Finance sit in the design team under one named owner. Step six, create short-term wins: pilot in one territory and share the results. Step eight, anchor the change in the culture: make the quarterly review permanent. Kotter assumes there is a sponsor who can drive change, and the named owner is that person. Both models describe attitudes, though. Neither shows whether the law will accept the ledger.</a:t>
             </a:r>
           </a:p>
           <a:p>
@@ -953,7 +953,7 @@
               <a:rPr>
                 <a:latin typeface="Times New Roman"/>
               </a:rPr>
-              <a:t>The main barrier is fear of answering for a wrongly coded payment, so I’d use dual sign-off, a manual override and a dispute freeze. And I’d train Legal, Rights Ops and Finance before the pilot on how the record works, how to read a smart-contract term, and when to freeze a payment.</a:t>
+              <a:t>The main barrier is fear of answering for a wrongly coded payment, so the plan uses dual sign-off, a manual override and a dispute freeze. Legal, Rights Ops and Finance staff should also be trained before the pilot on how the record works, how to read a smart-contract term, and when to freeze a payment.</a:t>
             </a:r>
           </a:p>
         </p:txBody>
@@ -1026,7 +1026,7 @@
               <a:rPr>
                 <a:latin typeface="Times New Roman"/>
               </a:rPr>
-              <a:t>Apple TV+ is growing. It clears music rights for its shows and negotiates talent deals across the same territories, and in 2024 it hired a licensing executive to take its originals to other platforms (9to5Mac, 2024). Every new platform and territory adds more parties and more rights windows, and Legal, Rights Ops and Finance still reconcile most of this by hand. So the question is how Apple TV+ keeps payments accurate and trusted as it grows, instead of paying for disputes afterwards.</a:t>
+              <a:t>Apple TV+ is growing. It clears music rights for its shows and negotiates talent deals across the same territories, and in 2024 it hired a licensing executive to take its originals to other platforms (9to5Mac, 2024). Every new platform and territory adds more parties and more rights windows, and Legal, Rights Ops and Finance still reconcile most of this by hand. The question is how Apple TV+ keeps payments accurate and trusted as it grows, instead of paying for disputes afterwards.</a:t>
             </a:r>
           </a:p>
           <a:p>
@@ -1034,7 +1034,7 @@
               <a:rPr>
                 <a:latin typeface="Times New Roman"/>
               </a:rPr>
-              <a:t>The music industry shows what can go wrong, so I use it as an example. The Mechanical Licensing Collective is holding over $424 million in streaming royalties that were collected but never matched to the people owed them (Billboard, 2023). Sharp (2023) argues this is what manual matching looks like when there are too many rights holders and territories. Of course, that is a music figure, not Apple TV+’s own loss. What carries over is the pattern: manual matching breaks down as the number of parties grows.</a:t>
+              <a:t>The music industry shows what can go wrong, so it is used here as an example. The Mechanical Licensing Collective is holding over $424 million in streaming royalties that were collected but never matched to the people owed them (Billboard, 2023). Sharp (2023) argues this is what manual matching looks like when there are too many rights holders and territories. That is a music figure, not Apple TV+’s own loss. What carries over is the pattern: manual matching breaks down as the number of parties grows.</a:t>
             </a:r>
           </a:p>
           <a:p>
@@ -1042,7 +1042,7 @@
               <a:rPr>
                 <a:latin typeface="Times New Roman"/>
               </a:rPr>
-              <a:t>Disputes also take a long time to settle. The Copyright Royalty Board set a streaming rate in 2018, it was appealed within months, and it wasn’t final until August 2023 (U.S. Copyright Royalty Board, 2023). A private dispute across several countries has no referee like that.</a:t>
+              <a:t>Disputes also take a long time to settle. The Copyright Royalty Board set a streaming rate in 2018, it was appealed within months, and it was not final until August 2023 (U.S. Copyright Royalty Board, 2023). A private dispute across several countries has no referee like that.</a:t>
             </a:r>
           </a:p>
           <a:p>
@@ -1050,7 +1050,7 @@
               <a:rPr>
                 <a:latin typeface="Times New Roman"/>
               </a:rPr>
-              <a:t>Someone might say this is a music problem, not a film and TV one. But Apple TV+ clears music rights and talent deals in the same territories, so the same structure applies, and it grows with the licensing plan. So before any pilot, Apple TV+ should measure its own dispute rate and reconciliation cost. Then any benefit we claim later can be checked against a real baseline.</a:t>
+              <a:t>It could be argued that this is a music problem, not a film and TV one. But Apple TV+ clears music rights and talent deals in the same territories, so the same structure applies, and it grows with the licensing plan. Before any pilot, therefore, Apple TV+ should measure its own dispute rate and reconciliation cost, so that any benefit claimed later can be checked against a real baseline.</a:t>
             </a:r>
           </a:p>
         </p:txBody>
@@ -1139,7 +1139,7 @@
               <a:rPr>
                 <a:latin typeface="Times New Roman"/>
               </a:rPr>
-              <a:t>I’ll keep the technology simple. A blockchain has three ideas. First, blocks. Each record sits in a block linked to the one before it, so if someone changes an old record, the chain breaks and everyone can see it. Second, shared copies. Talent, rights holders and Apple TV+ each hold a copy, so nobody has to simply trust one administrator. Third, the smart contract. The licensing rules are written as code, so when a rights window opens the royalty calculation and payment can start without someone checking by hand.</a:t>
+              <a:t>A blockchain has three ideas. First, blocks. Each record sits in a block linked to the one before it, so if an old record is changed, the chain breaks and everyone can see it. Second, shared copies. Talent, rights holders and Apple TV+ each hold a copy, so nobody has to simply trust one administrator. Third, the smart contract. The licensing rules are written as code, so when a rights window opens the royalty calculation and payment can start without anyone checking by hand.</a:t>
             </a:r>
           </a:p>
           <a:p>
@@ -1147,7 +1147,7 @@
               <a:rPr>
                 <a:latin typeface="Times New Roman"/>
               </a:rPr>
-              <a:t>You might ask why this isn’t just a better rights database. The problem with a normal database is that everyone has to trust whoever runs it, and in a multi-party deal that is often one of the counterparties. A shared ledger lets each party check the record for themselves. Zhao and O’Mahony (2018) built a working prototype for music rights, so we know it can be done. García et al. (2023) say research has moved on from “does it work?” to the legal and business questions, which is where this briefing sits. But a shared ledger is only useful if the other parties actually join it. So its value depends on talent and rights holders taking part, which is as much a relationship job as a technical one.</a:t>
+              <a:t>A fair question is why this is not simply a better rights database. The problem with a normal database is that everyone has to trust whoever runs it, and in a multi-party deal that is often one of the counterparties. A shared ledger lets each party check the record for themselves. Zhao and O’Mahony (2018) built a working prototype for music rights, so the approach is known to be workable. García et al. (2023) say research has moved on from whether it works to the legal and business questions, which is where this briefing sits. But a shared ledger is only useful if the other parties actually join it. Its value depends on talent and rights holders taking part, which is as much a relationship job as a technical one.</a:t>
             </a:r>
           </a:p>
           <a:p>
@@ -1155,7 +1155,7 @@
               <a:rPr>
                 <a:latin typeface="Times New Roman"/>
               </a:rPr>
-              <a:t>For a definition, I’ll use Iansiti and Lakhani (2017): an open, distributed ledger that records transactions between two parties in a way that can be verified and can’t be changed, and that can be programmed to trigger transactions automatically. They call it a foundational technology, like the internet, which changes things slowly rather than overnight. That fits here. Apple TV+ isn’t replacing its business. It is changing how a record is shared.</a:t>
+              <a:t>For a definition, Iansiti and Lakhani (2017) describe an open, distributed ledger that records transactions between two parties in a way that can be verified and cannot be changed, and that can be programmed to trigger transactions automatically. They call it a foundational technology, like the internet, which changes things slowly rather than overnight. That fits here. Apple TV+ is not replacing its business. It is changing how a record is shared.</a:t>
             </a:r>
           </a:p>
         </p:txBody>
@@ -1244,7 +1244,7 @@
               <a:rPr>
                 <a:latin typeface="Times New Roman"/>
               </a:rPr>
-              <a:t>The key point is that the contract doesn’t wait for someone to enforce it. The trigger sits inside the ledger. When a rights window opens in a territory, the calculation and payment can start right then. At the moment, the EU, APAC and US windows open on different dates, and each one needs someone to confirm it and someone to pay it.</a:t>
+              <a:t>The key point is that the contract does not wait for someone to enforce it. The trigger sits inside the ledger. When a rights window opens in a territory, the calculation and payment can start right then. At the moment, the EU, APAC and US windows open on different dates, and each one needs someone to confirm it and someone to pay it.</a:t>
             </a:r>
           </a:p>
           <a:p>
@@ -1252,7 +1252,7 @@
               <a:rPr>
                 <a:latin typeface="Times New Roman"/>
               </a:rPr>
-              <a:t>Williamson’s (1979) transaction cost economics helps explain why that matters. His idea is that firms organise a deal so that contracting costs stay low, including the cost of monitoring and enforcing it. Checking that a window has opened is a monitoring cost. So automating the trigger changes how the deal is governed, not just how fast it runs. But the theory cuts both ways. Writing terms as code, auditing the code and running the platform are costs too. So the ledger only pays off where the monitoring it saves is worth more than that. That points to territories with frequent, standard payments, and away from rare, heavily negotiated deals. In practice, Apple TV+ can count the saving as fewer manual confirmation steps per territory.</a:t>
+              <a:t>Williamson’s (1979) transaction cost economics helps explain why that matters. The idea is that firms organise a deal so that contracting costs stay low, including the cost of monitoring and enforcing it. Checking that a window has opened is a monitoring cost, so automating the trigger changes how the deal is governed, not just how fast it runs. But the theory cuts both ways. Writing terms as code, auditing the code and running the platform are costs too, so the ledger only pays off where the monitoring it saves is worth more than that. That points to territories with frequent, standard payments, and away from rare, heavily negotiated deals. In practice, Apple TV+ can count the saving as fewer manual confirmation steps per territory.</a:t>
             </a:r>
           </a:p>
           <a:p>
@@ -1260,7 +1260,7 @@
               <a:rPr>
                 <a:latin typeface="Times New Roman"/>
               </a:rPr>
-              <a:t>There is one limit. Williamson can show the ledger may be a cheaper way to govern a deal. He can’t tell us whether a court in every country would accept an automatic payment as legally binding. That legal gap is what the next slides deal with.</a:t>
+              <a:t>There is one limit. Williamson can show the ledger may be a cheaper way to govern a deal, but not whether a court in every country would accept an automatic payment as legally binding. That legal gap is what the next slides deal with.</a:t>
             </a:r>
           </a:p>
         </p:txBody>
@@ -1349,7 +1349,7 @@
               <a:rPr>
                 <a:latin typeface="Times New Roman"/>
               </a:rPr>
-              <a:t>Here are the benefits and the limits side by side. The benefits are fewer errors and disputes, because automatic triggers take away discretion over when and how royalties are paid; one record that everyone can audit; and faster payment that scales, because a new territory just adds a trigger. The limits are legal enforceability, cost and integration, and skills and coding risk.</a:t>
+              <a:t>The slide sets the benefits and the limits side by side. The benefits are fewer errors and disputes, because automatic triggers take away discretion over when and how royalties are paid; one record that everyone can audit; and faster payment that scales, because a new territory just adds a trigger. The limits are legal enforceability, cost and integration, and skills and coding risk.</a:t>
             </a:r>
           </a:p>
           <a:p>
@@ -1357,7 +1357,7 @@
               <a:rPr>
                 <a:latin typeface="Times New Roman"/>
               </a:rPr>
-              <a:t>Jensen and Meckling’s (1976) agency theory explains the first benefit. Agency costs appear when someone hands decisions to another party whose interests may differ. Taking discretion out of the payment calculation reduces that cost, and the $424 million on slide two is really an example of it. But the theory only goes so far. Removing discretion helps with routine payments. Many royalty disputes come from unclear terms, and code can’t fix unclear terms.</a:t>
+              <a:t>Jensen and Meckling’s (1976) agency theory explains the first benefit. Agency costs appear when someone hands decisions to another party whose interests may differ. Taking discretion out of the payment calculation reduces that cost, and the $424 million on slide two is really an example of it. But the theory only goes so far. Removing discretion helps with routine payments, yet many royalty disputes come from unclear terms, and code cannot fix unclear terms.</a:t>
             </a:r>
           </a:p>
           <a:p>
@@ -1373,7 +1373,7 @@
               <a:rPr>
                 <a:latin typeface="Times New Roman"/>
               </a:rPr>
-              <a:t>On cost and skills, Deloitte’s 2019 Global Blockchain Survey found that 28% of executives cite uncertain return on investment and 28% cite a lack of in-house skills (I took these figures from secondary coverage). They matter for Apple TV+ too. The ledger has to connect to the contract and finance systems already in use, or it just becomes a fourth record. And someone has to translate legal terms into code, which is where lawyers and developers can talk past each other. So each limit needs an answer, and the later slides give one: sign-off for the coding risk, a phased rollout for enforceability, and a one-territory pilot to test integration.</a:t>
+              <a:t>On cost and skills, Deloitte’s 2019 Global Blockchain Survey found that 28% of executives cite uncertain return on investment and 28% cite a lack of in-house skills (figures taken from secondary coverage). These matter for Apple TV+ too. The ledger has to connect to the contract and finance systems already in use, or it becomes a fourth record. And someone has to translate legal terms into code, which is where lawyers and developers can talk past each other. Each limit therefore needs an answer, and the later slides give one: sign-off for the coding risk, a phased rollout for enforceability, and a one-territory pilot to test integration.</a:t>
             </a:r>
           </a:p>
           <a:p>
@@ -1470,7 +1470,7 @@
               <a:rPr>
                 <a:latin typeface="Times New Roman"/>
               </a:rPr>
-              <a:t>Right now, three teams each keep their own version of the same royalty information. Legal holds the contract terms, Rights Ops tracks territories and windows, and Finance holds the payments. They only check against each other from time to time. A shared ledger doesn’t just make that check faster. It removes most of the need for it.</a:t>
+              <a:t>Right now, three teams each keep their own version of the same royalty information. Legal holds the contract terms, Rights Ops tracks territories and windows, and Finance holds the payments. They only check against each other from time to time. A shared ledger does not just make that check faster. It removes most of the need for it.</a:t>
             </a:r>
           </a:p>
           <a:p>
@@ -1478,7 +1478,7 @@
               <a:rPr>
                 <a:latin typeface="Times New Roman"/>
               </a:rPr>
-              <a:t>The work itself changes, not only the speed. Legal stops reviewing after the event and starts checking terms as they are written into the system. Rights Ops stops chasing people to confirm a window has opened and watches the ledger triggers instead. Finance stops sorting out disputed claims and audits a record that is already reconciled. That is a real change in skills, so the worries on the next slide aren’t just resistance to change.</a:t>
+              <a:t>The work itself changes, not only the speed. Legal stops reviewing after the event and starts checking terms as they are written into the system. Rights Ops stops chasing people to confirm a window has opened and watches the ledger triggers instead. Finance stops sorting out disputed claims and audits a record that is already reconciled. That is a real change in skills, so the concerns on the next slide are not just resistance to change.</a:t>
             </a:r>
           </a:p>
           <a:p>
@@ -1486,7 +1486,7 @@
               <a:rPr>
                 <a:latin typeface="Times New Roman"/>
               </a:rPr>
-              <a:t>On structure and culture, I’d form one small team with a single named owner in place of three separate reconciliations. Culturally, people have to trust a record they didn’t create themselves, and that takes training and shared accountability.</a:t>
+              <a:t>On structure and culture, the proposal is one small team with a single named owner in place of three separate reconciliations. Culturally, people have to trust a record they did not create themselves, and that takes training and shared accountability.</a:t>
             </a:r>
           </a:p>
           <a:p>
@@ -1494,7 +1494,7 @@
               <a:rPr>
                 <a:latin typeface="Times New Roman"/>
               </a:rPr>
-              <a:t>I also used Porter’s (1985) value chain to see where the ledger bites. In technology development, royalty rules become tested code that Legal and engineers sign off together. In inbound logistics, which for a streamer means receiving content and talent rights, windows and payment terms come from one shared record instead of being re-confirmed by hand in each territory. Porter’s point is that the benefit is spread across activities, which is why one named owner matters. Without one, each function improves its own step and the ledger becomes a fourth record. So this is really an organisational design choice, not only a technology choice.</a:t>
+              <a:t>Porter’s (1985) value chain shows where the ledger has its effect. In technology development, royalty rules become tested code that Legal and engineers sign off together. In inbound logistics, which for a streamer means receiving content and talent rights, windows and payment terms come from one shared record instead of being re-confirmed by hand in each territory. Porter’s point is that the benefit is spread across activities, which is why one named owner matters. Without one, each function improves its own step and the ledger becomes a fourth record. This makes it an organisational design choice, not only a technology choice.</a:t>
             </a:r>
           </a:p>
         </p:txBody>
@@ -1583,7 +1583,7 @@
               <a:rPr>
                 <a:latin typeface="Times New Roman"/>
               </a:rPr>
-              <a:t>I focus on legal and rights teams. They aren’t against change by habit. They are the people who would have to answer to a regulator or a court if something went wrong, so their concerns are professional ones.</a:t>
+              <a:t>The focus is legal and rights teams. They are not against change by habit. They are the people who would have to answer to a regulator or a court if something went wrong, so their concerns are professional ones.</a:t>
             </a:r>
           </a:p>
           <a:p>
@@ -1591,7 +1591,7 @@
               <a:rPr>
                 <a:latin typeface="Times New Roman"/>
               </a:rPr>
-              <a:t>They have three. The first is regulation: which country’s law applies to a cross-border smart-contract payment dispute, and an unchangeable ledger can clash with GDPR rights to correct or delete personal data (European Parliament and Council, 2016; Finck, 2018). The second is enforceability. Correct execution doesn’t guarantee a binding payment, and Werbach and Cornell (2017) and Levy (2017) both argue that smart contracts don’t replace contract law. The third is integration. The ledger has to work with the contract and finance systems already in use, or it recreates the three-way reconciliation problem.</a:t>
+              <a:t>There are three. The first is regulation: which country’s law applies to a cross-border smart-contract payment dispute, and an unchangeable ledger can clash with GDPR rights to correct or delete personal data (European Parliament and Council, 2016; Finck, 2018). The second is enforceability. Correct execution does not guarantee a binding payment, and Werbach and Cornell (2017) and Levy (2017) both argue that smart contracts do not replace contract law. The third is integration. The ledger has to work with the contract and finance systems already in use, or it recreates the three-way reconciliation problem.</a:t>
             </a:r>
           </a:p>
           <a:p>
@@ -1599,7 +1599,7 @@
               <a:rPr>
                 <a:latin typeface="Times New Roman"/>
               </a:rPr>
-              <a:t>Underneath all three is the same gap: there is little settled case law on smart-contract royalties. Legal teams are being asked to approve something the law hasn’t caught up with.</a:t>
+              <a:t>Underneath all three is the same gap: there is little settled case law on smart-contract royalties. Legal teams are being asked to approve something the law has not caught up with.</a:t>
             </a:r>
           </a:p>
           <a:p>
@@ -1607,7 +1607,7 @@
               <a:rPr>
                 <a:latin typeface="Times New Roman"/>
               </a:rPr>
-              <a:t>So my answer is about sequencing, not reassurance. Start in territories where digital-contract rules are clearer, keep personal data off the ledger, pilot in one territory with Legal in the design team, and keep a standing legal review as territories are added. The written contract stays the master and the ledger just carries it out. That follows from Werbach and Cornell: the ledger can only run a contract the law already recognises. So Legal should be a design authority, not a late reviewer, and its approval is the real gate for each new territory.</a:t>
+              <a:t>The response is about sequencing, not reassurance. Start in territories where digital-contract rules are clearer, keep personal data off the ledger, pilot in one territory with Legal in the design team, and keep a standing legal review as territories are added. The written contract stays the master and the ledger just carries it out. This follows from Werbach and Cornell: the ledger can only run a contract the law already recognises. Legal should therefore be a design authority, not a late reviewer, and its approval is the real gate for each new territory.</a:t>
             </a:r>
           </a:p>
         </p:txBody>
@@ -1713,7 +1713,7 @@
               <a:rPr>
                 <a:latin typeface="Times New Roman"/>
               </a:rPr>
-              <a:t>I’d call this a resource-based argument rather than a technology one. Accurate payments build a track record that rivals can’t simply buy. But it cuts both ways. One visible error damages trust faster than many correct payments build it. So the sign-off controls on slide eleven protect the strategy as well as the money. And the link can be tested: do dispute numbers fall, and can new territories and partners be added faster?</a:t>
+              <a:t>This is a resource-based argument rather than a technology one. Accurate payments build a track record that rivals cannot simply buy. But it cuts both ways. One visible error damages trust faster than many correct payments build it, so the sign-off controls on slide eleven protect the strategy as well as the money. The link can also be tested: do dispute numbers fall, and can new territories and partners be added faster?</a:t>
             </a:r>
           </a:p>
           <a:p>
@@ -1721,7 +1721,7 @@
               <a:rPr>
                 <a:latin typeface="Times New Roman"/>
               </a:rPr>
-              <a:t>One assumption needs checking. The ledger is only a differentiator while competitors don’t have one. Whether the advantage lasts is the next slide.</a:t>
+              <a:t>One assumption needs checking. The ledger is only a differentiator while competitors do not have one. Whether the advantage lasts is the subject of the next slide.</a:t>
             </a:r>
           </a:p>
         </p:txBody>
@@ -1811,7 +1811,7 @@
               <a:rPr>
                 <a:latin typeface="Times New Roman"/>
               </a:rPr>
-              <a:t>Being early is a real advantage, but staying ahead is a different claim, and I don’t think the evidence supports it without qualification.</a:t>
+              <a:t>Being early is a real advantage, but staying ahead is a different claim, and the evidence does not support it without qualification.</a:t>
             </a:r>
           </a:p>
           <a:p>
@@ -1827,7 +1827,7 @@
               <a:rPr>
                 <a:latin typeface="Times New Roman"/>
               </a:rPr>
-              <a:t>There is a fair counterargument. Talent already on Apple’s ledger has a payment history and little reason to leave just because a rival adopts something similar. So the technology advantage may fade while the relationship advantage lasts longer. That is my claim: the advantage is built on relationships and builds up over time. It is not built on technology. Trust is also lopsided. Talent will judge Apple TV+ on its worst payment, not its average one, so the advantage is only as strong as the error controls on slide eleven. So I treat the ledger as the foundation of a relationship strategy, not the advantage itself, and I’d review this every year.</a:t>
+              <a:t>There is a fair counterargument. Talent already on Apple’s ledger has a payment history and little reason to leave just because a rival adopts something similar. The technology advantage may therefore fade while the relationship advantage lasts longer. That is the claim made here: the advantage is built on relationships and builds up over time. It is not built on technology. Trust is also lopsided. Talent will judge Apple TV+ on its worst payment, not its average one, so the advantage is only as strong as the error controls on slide eleven. The ledger is therefore treated as the foundation of a relationship strategy, not the advantage itself, and the position should be reviewed every year.</a:t>
             </a:r>
           </a:p>
           <a:p>
@@ -1835,7 +1835,7 @@
               <a:rPr>
                 <a:latin typeface="Times New Roman"/>
               </a:rPr>
-              <a:t>Using Barney’s (1991) VRIO test: is it valuable? Yes, mainly because it means fewer disputes. Is it rare? Yes, for now. My searches found no major video streamer running a rights ledger, only music efforts such as Spotify’s 2017 purchase of Mediachain and vendor platforms like Tech Mahindra’s bCRMS. That isn’t proof that none exist. Is it hard to imitate? The code is easy to copy. The payment history isn’t. Is Apple TV+ organised to capture it? Not yet. A named owner and team are proposed on slide six, but dual sign-off and a standing legal review still need to be set up, so this is the weakest test today. Barney assumes a stable resource, but here the record of payments grows with use, so the advantage depends on starting early and running without visible errors. My verdict: the advantage is temporary until the organisation and the trust are built.</a:t>
+              <a:t>Using Barney’s (1991) VRIO test: is it valuable? Yes, mainly because it means fewer disputes. Is it rare? Yes, for now. Searches found no major video streamer running a rights ledger, only music efforts such as Spotify’s 2017 purchase of Mediachain and vendor platforms like Tech Mahindra’s bCRMS. That is not proof that none exist. Is it hard to imitate? The code is easy to copy. The payment history is not. Is Apple TV+ organised to capture it? Not yet. A named owner and team are proposed on slide six, but dual sign-off and a standing legal review still need to be set up, so this is the weakest test today. Barney assumes a stable resource, but here the record of payments grows with use, so the advantage depends on starting early and running without visible errors. The verdict is that the advantage is temporary until the organisation and the trust are built.</a:t>
             </a:r>
           </a:p>
         </p:txBody>
@@ -8289,7 +8289,7 @@
                 </a:solidFill>
                 <a:latin typeface="Times New Roman"/>
               </a:rPr>
-              <a:t>What we gain, what holds us back</a:t>
+              <a:t>What is gained, what holds it back</a:t>
             </a:r>
           </a:p>
         </p:txBody>
@@ -10598,7 +10598,7 @@
                 </a:solidFill>
                 <a:latin typeface="Times New Roman"/>
               </a:rPr>
-              <a:t>V and R pass, I passes on trust alone, O is not yet met, so the advantage is temporary until the team and trust are built.</a:t>
+              <a:t>Valuable and Rare pass, Hard to imitate passes on trust alone, Organised is not yet met, so the advantage is temporary.</a:t>
             </a:r>
           </a:p>
         </p:txBody>
@@ -22858,7 +22858,7 @@
                 </a:solidFill>
                 <a:latin typeface="Times New Roman"/>
               </a:rPr>
-              <a:t>OUR RESPONSE</a:t>
+              <a:t>RESPONSE</a:t>
             </a:r>
           </a:p>
         </p:txBody>
@@ -23158,7 +23158,7 @@
                 </a:solidFill>
                 <a:latin typeface="Times New Roman"/>
               </a:rPr>
-              <a:t>OUR RESPONSE</a:t>
+              <a:t>RESPONSE</a:t>
             </a:r>
           </a:p>
         </p:txBody>
@@ -23458,7 +23458,7 @@
                 </a:solidFill>
                 <a:latin typeface="Times New Roman"/>
               </a:rPr>
-              <a:t>OUR RESPONSE</a:t>
+              <a:t>RESPONSE</a:t>
             </a:r>
           </a:p>
         </p:txBody>

</xml_diff>